<commit_message>
Phase 4: quiz pilot (22 lessons, batch) + cost estimate; 5-7 question default
Co-Authored-By: Claude Opus 5.5 (1M context) <noreply@anthropic.com>
</commit_message>
<xml_diff>
--- a/data/outputs/v2/Biology/SS2.1_Plant_Nutrition/quiz/Biology_G10_SS2.1_Plant_Nutrition_L2_QuickCheck.pptx
+++ b/data/outputs/v2/Biology/SS2.1_Plant_Nutrition/quiz/Biology_G10_SS2.1_Plant_Nutrition_L2_QuickCheck.pptx
@@ -14,12 +14,9 @@
     <p:sldId id="262" r:id="rId8"/>
     <p:sldId id="263" r:id="rId9"/>
     <p:sldId id="264" r:id="rId10"/>
-    <p:sldId id="265" r:id="rId11"/>
-    <p:sldId id="266" r:id="rId12"/>
-    <p:sldId id="267" r:id="rId13"/>
   </p:sldIdLst>
   <p:notesMasterIdLst>
-    <p:notesMasterId r:id="rId14"/>
+    <p:notesMasterId r:id="rId11"/>
   </p:notesMasterIdLst>
   <p:sldSz cx="12192000" cy="6858000"/>
   <p:notesSz cx="6858000" cy="12192000"/>
@@ -537,270 +534,6 @@
             <a:fld id="{F7021451-1387-4CA6-816F-3879F97B5CBC}" type="slidenum">
               <a:rPr lang="en-US"/>
               <a:t>1</a:t>
-            </a:fld>
-            <a:endParaRPr lang="en-US"/>
-          </a:p>
-        </p:txBody>
-      </p:sp>
-    </p:spTree>
-    <p:extLst>
-      <p:ext uri="{BB962C8B-B14F-4D97-AF65-F5344CB8AC3E}">
-        <p14:creationId xmlns:p14="http://schemas.microsoft.com/office/powerpoint/2010/main" val="1024086991"/>
-      </p:ext>
-    </p:extLst>
-  </p:cSld>
-  <p:clrMapOvr>
-    <a:masterClrMapping/>
-  </p:clrMapOvr>
-</p:notes>
-</file>
-
-<file path=ppt/notesSlides/notesSlide10.xml><?xml version="1.0" encoding="utf-8"?>
-<p:notes xmlns:a="http://schemas.openxmlformats.org/drawingml/2006/main" xmlns:r="http://schemas.openxmlformats.org/officeDocument/2006/relationships" xmlns:p="http://schemas.openxmlformats.org/presentationml/2006/main">
-  <p:cSld>
-    <p:spTree>
-      <p:nvGrpSpPr>
-        <p:cNvPr id="1" name=""/>
-        <p:cNvGrpSpPr/>
-        <p:nvPr/>
-      </p:nvGrpSpPr>
-      <p:grpSpPr>
-        <a:xfrm>
-          <a:off x="0" y="0"/>
-          <a:ext cx="0" cy="0"/>
-          <a:chOff x="0" y="0"/>
-          <a:chExt cx="0" cy="0"/>
-        </a:xfrm>
-      </p:grpSpPr>
-      <p:sp>
-        <p:nvSpPr>
-          <p:cNvPr id="2" name="Slide Image Placeholder 1"/>
-          <p:cNvSpPr>
-            <a:spLocks noGrp="1" noRot="1" noChangeAspect="1"/>
-          </p:cNvSpPr>
-          <p:nvPr>
-            <p:ph type="sldImg"/>
-          </p:nvPr>
-        </p:nvSpPr>
-        <p:spPr/>
-      </p:sp>
-      <p:sp>
-        <p:nvSpPr>
-          <p:cNvPr id="3" name="Notes Placeholder 2"/>
-          <p:cNvSpPr>
-            <a:spLocks noGrp="1"/>
-          </p:cNvSpPr>
-          <p:nvPr>
-            <p:ph type="body" idx="1"/>
-          </p:nvPr>
-        </p:nvSpPr>
-        <p:spPr/>
-        <p:txBody>
-          <a:bodyPr/>
-          <a:lstStyle/>
-          <a:p>
-            <a:r>
-              <a:rPr lang="en-US" dirty="0"/>
-              <a:t/>
-            </a:r>
-            <a:endParaRPr lang="en-US" dirty="0"/>
-          </a:p>
-        </p:txBody>
-      </p:sp>
-      <p:sp>
-        <p:nvSpPr>
-          <p:cNvPr id="4" name="Slide Number Placeholder 3"/>
-          <p:cNvSpPr>
-            <a:spLocks noGrp="1"/>
-          </p:cNvSpPr>
-          <p:nvPr>
-            <p:ph type="sldNum" sz="quarter" idx="10"/>
-          </p:nvPr>
-        </p:nvSpPr>
-        <p:spPr/>
-        <p:txBody>
-          <a:bodyPr/>
-          <a:lstStyle/>
-          <a:p>
-            <a:fld id="{F7021451-1387-4CA6-816F-3879F97B5CBC}" type="slidenum">
-              <a:rPr lang="en-US"/>
-              <a:t>10</a:t>
-            </a:fld>
-            <a:endParaRPr lang="en-US"/>
-          </a:p>
-        </p:txBody>
-      </p:sp>
-    </p:spTree>
-    <p:extLst>
-      <p:ext uri="{BB962C8B-B14F-4D97-AF65-F5344CB8AC3E}">
-        <p14:creationId xmlns:p14="http://schemas.microsoft.com/office/powerpoint/2010/main" val="1024086991"/>
-      </p:ext>
-    </p:extLst>
-  </p:cSld>
-  <p:clrMapOvr>
-    <a:masterClrMapping/>
-  </p:clrMapOvr>
-</p:notes>
-</file>
-
-<file path=ppt/notesSlides/notesSlide11.xml><?xml version="1.0" encoding="utf-8"?>
-<p:notes xmlns:a="http://schemas.openxmlformats.org/drawingml/2006/main" xmlns:r="http://schemas.openxmlformats.org/officeDocument/2006/relationships" xmlns:p="http://schemas.openxmlformats.org/presentationml/2006/main">
-  <p:cSld>
-    <p:spTree>
-      <p:nvGrpSpPr>
-        <p:cNvPr id="1" name=""/>
-        <p:cNvGrpSpPr/>
-        <p:nvPr/>
-      </p:nvGrpSpPr>
-      <p:grpSpPr>
-        <a:xfrm>
-          <a:off x="0" y="0"/>
-          <a:ext cx="0" cy="0"/>
-          <a:chOff x="0" y="0"/>
-          <a:chExt cx="0" cy="0"/>
-        </a:xfrm>
-      </p:grpSpPr>
-      <p:sp>
-        <p:nvSpPr>
-          <p:cNvPr id="2" name="Slide Image Placeholder 1"/>
-          <p:cNvSpPr>
-            <a:spLocks noGrp="1" noRot="1" noChangeAspect="1"/>
-          </p:cNvSpPr>
-          <p:nvPr>
-            <p:ph type="sldImg"/>
-          </p:nvPr>
-        </p:nvSpPr>
-        <p:spPr/>
-      </p:sp>
-      <p:sp>
-        <p:nvSpPr>
-          <p:cNvPr id="3" name="Notes Placeholder 2"/>
-          <p:cNvSpPr>
-            <a:spLocks noGrp="1"/>
-          </p:cNvSpPr>
-          <p:nvPr>
-            <p:ph type="body" idx="1"/>
-          </p:nvPr>
-        </p:nvSpPr>
-        <p:spPr/>
-        <p:txBody>
-          <a:bodyPr/>
-          <a:lstStyle/>
-          <a:p>
-            <a:r>
-              <a:rPr lang="en-US" dirty="0"/>
-              <a:t/>
-            </a:r>
-            <a:endParaRPr lang="en-US" dirty="0"/>
-          </a:p>
-        </p:txBody>
-      </p:sp>
-      <p:sp>
-        <p:nvSpPr>
-          <p:cNvPr id="4" name="Slide Number Placeholder 3"/>
-          <p:cNvSpPr>
-            <a:spLocks noGrp="1"/>
-          </p:cNvSpPr>
-          <p:nvPr>
-            <p:ph type="sldNum" sz="quarter" idx="10"/>
-          </p:nvPr>
-        </p:nvSpPr>
-        <p:spPr/>
-        <p:txBody>
-          <a:bodyPr/>
-          <a:lstStyle/>
-          <a:p>
-            <a:fld id="{F7021451-1387-4CA6-816F-3879F97B5CBC}" type="slidenum">
-              <a:rPr lang="en-US"/>
-              <a:t>11</a:t>
-            </a:fld>
-            <a:endParaRPr lang="en-US"/>
-          </a:p>
-        </p:txBody>
-      </p:sp>
-    </p:spTree>
-    <p:extLst>
-      <p:ext uri="{BB962C8B-B14F-4D97-AF65-F5344CB8AC3E}">
-        <p14:creationId xmlns:p14="http://schemas.microsoft.com/office/powerpoint/2010/main" val="1024086991"/>
-      </p:ext>
-    </p:extLst>
-  </p:cSld>
-  <p:clrMapOvr>
-    <a:masterClrMapping/>
-  </p:clrMapOvr>
-</p:notes>
-</file>
-
-<file path=ppt/notesSlides/notesSlide12.xml><?xml version="1.0" encoding="utf-8"?>
-<p:notes xmlns:a="http://schemas.openxmlformats.org/drawingml/2006/main" xmlns:r="http://schemas.openxmlformats.org/officeDocument/2006/relationships" xmlns:p="http://schemas.openxmlformats.org/presentationml/2006/main">
-  <p:cSld>
-    <p:spTree>
-      <p:nvGrpSpPr>
-        <p:cNvPr id="1" name=""/>
-        <p:cNvGrpSpPr/>
-        <p:nvPr/>
-      </p:nvGrpSpPr>
-      <p:grpSpPr>
-        <a:xfrm>
-          <a:off x="0" y="0"/>
-          <a:ext cx="0" cy="0"/>
-          <a:chOff x="0" y="0"/>
-          <a:chExt cx="0" cy="0"/>
-        </a:xfrm>
-      </p:grpSpPr>
-      <p:sp>
-        <p:nvSpPr>
-          <p:cNvPr id="2" name="Slide Image Placeholder 1"/>
-          <p:cNvSpPr>
-            <a:spLocks noGrp="1" noRot="1" noChangeAspect="1"/>
-          </p:cNvSpPr>
-          <p:nvPr>
-            <p:ph type="sldImg"/>
-          </p:nvPr>
-        </p:nvSpPr>
-        <p:spPr/>
-      </p:sp>
-      <p:sp>
-        <p:nvSpPr>
-          <p:cNvPr id="3" name="Notes Placeholder 2"/>
-          <p:cNvSpPr>
-            <a:spLocks noGrp="1"/>
-          </p:cNvSpPr>
-          <p:nvPr>
-            <p:ph type="body" idx="1"/>
-          </p:nvPr>
-        </p:nvSpPr>
-        <p:spPr/>
-        <p:txBody>
-          <a:bodyPr/>
-          <a:lstStyle/>
-          <a:p>
-            <a:r>
-              <a:rPr lang="en-US" dirty="0"/>
-              <a:t/>
-            </a:r>
-            <a:endParaRPr lang="en-US" dirty="0"/>
-          </a:p>
-        </p:txBody>
-      </p:sp>
-      <p:sp>
-        <p:nvSpPr>
-          <p:cNvPr id="4" name="Slide Number Placeholder 3"/>
-          <p:cNvSpPr>
-            <a:spLocks noGrp="1"/>
-          </p:cNvSpPr>
-          <p:nvPr>
-            <p:ph type="sldNum" sz="quarter" idx="10"/>
-          </p:nvPr>
-        </p:nvSpPr>
-        <p:spPr/>
-        <p:txBody>
-          <a:bodyPr/>
-          <a:lstStyle/>
-          <a:p>
-            <a:fld id="{F7021451-1387-4CA6-816F-3879F97B5CBC}" type="slidenum">
-              <a:rPr lang="en-US"/>
-              <a:t>12</a:t>
             </a:fld>
             <a:endParaRPr lang="en-US"/>
           </a:p>
@@ -2004,7 +1737,7 @@
                 <a:ea typeface="Arial" pitchFamily="34" charset="-122"/>
                 <a:cs typeface="Arial" pitchFamily="34" charset="-120"/>
               </a:rPr>
-              <a:t>10 multiple-choice questions  •  choose A, B, C or D</a:t>
+              <a:t>7 multiple-choice questions  •  choose A, B, C or D</a:t>
             </a:r>
             <a:endParaRPr lang="en-US" sz="1600" dirty="0"/>
           </a:p>
@@ -2120,1336 +1853,6 @@
               <a:t> (https://creativecommons.org/licenses/by-nc/4.0/).</a:t>
             </a:r>
             <a:endParaRPr lang="en-US" sz="900" dirty="0"/>
-          </a:p>
-        </p:txBody>
-      </p:sp>
-    </p:spTree>
-  </p:cSld>
-  <p:clrMapOvr>
-    <a:masterClrMapping/>
-  </p:clrMapOvr>
-</p:sld>
-</file>
-
-<file path=ppt/slides/slide10.xml><?xml version="1.0" encoding="utf-8"?>
-<p:sld xmlns:a="http://schemas.openxmlformats.org/drawingml/2006/main" xmlns:r="http://schemas.openxmlformats.org/officeDocument/2006/relationships" xmlns:p="http://schemas.openxmlformats.org/presentationml/2006/main">
-  <p:cSld name="Slide 10">
-    <p:bg>
-      <p:bgPr>
-        <a:solidFill>
-          <a:srgbClr val="6A4C93"/>
-        </a:solidFill>
-      </p:bgPr>
-    </p:bg>
-    <p:spTree>
-      <p:nvGrpSpPr>
-        <p:cNvPr id="1" name=""/>
-        <p:cNvGrpSpPr/>
-        <p:nvPr/>
-      </p:nvGrpSpPr>
-      <p:grpSpPr>
-        <a:xfrm>
-          <a:off x="0" y="0"/>
-          <a:ext cx="0" cy="0"/>
-          <a:chOff x="0" y="0"/>
-          <a:chExt cx="0" cy="0"/>
-        </a:xfrm>
-      </p:grpSpPr>
-      <p:sp>
-        <p:nvSpPr>
-          <p:cNvPr id="2" name="Text 0"/>
-          <p:cNvSpPr/>
-          <p:nvPr/>
-        </p:nvSpPr>
-        <p:spPr>
-          <a:xfrm>
-            <a:off x="548640" y="365760"/>
-            <a:ext cx="6400800" cy="365760"/>
-          </a:xfrm>
-          <a:prstGeom prst="rect">
-            <a:avLst/>
-          </a:prstGeom>
-          <a:noFill/>
-          <a:ln/>
-        </p:spPr>
-        <p:txBody>
-          <a:bodyPr wrap="square" lIns="0" tIns="0" rIns="0" bIns="0" rtlCol="0" anchor="ctr"/>
-          <a:lstStyle/>
-          <a:p>
-            <a:pPr indent="0" marL="0">
-              <a:buNone/>
-            </a:pPr>
-            <a:r>
-              <a:rPr lang="en-US" sz="1300" b="1" spc="200" kern="0" dirty="0">
-                <a:solidFill>
-                  <a:srgbClr val="E0D6F0"/>
-                </a:solidFill>
-                <a:latin typeface="Arial" pitchFamily="34" charset="0"/>
-                <a:ea typeface="Arial" pitchFamily="34" charset="-122"/>
-                <a:cs typeface="Arial" pitchFamily="34" charset="-120"/>
-              </a:rPr>
-              <a:t>QUESTION 9 OF 10</a:t>
-            </a:r>
-            <a:endParaRPr lang="en-US" sz="1300" dirty="0"/>
-          </a:p>
-        </p:txBody>
-      </p:sp>
-      <p:sp>
-        <p:nvSpPr>
-          <p:cNvPr id="3" name="Shape 1"/>
-          <p:cNvSpPr/>
-          <p:nvPr/>
-        </p:nvSpPr>
-        <p:spPr>
-          <a:xfrm>
-            <a:off x="8138160" y="320040"/>
-            <a:ext cx="3474720" cy="365760"/>
-          </a:xfrm>
-          <a:prstGeom prst="roundRect">
-            <a:avLst>
-              <a:gd name="adj" fmla="val 15000"/>
-            </a:avLst>
-          </a:prstGeom>
-          <a:solidFill>
-            <a:srgbClr val="5A3F80"/>
-          </a:solidFill>
-          <a:ln/>
-        </p:spPr>
-      </p:sp>
-      <p:sp>
-        <p:nvSpPr>
-          <p:cNvPr id="4" name="Text 2"/>
-          <p:cNvSpPr/>
-          <p:nvPr/>
-        </p:nvSpPr>
-        <p:spPr>
-          <a:xfrm>
-            <a:off x="8138160" y="320040"/>
-            <a:ext cx="3474720" cy="365760"/>
-          </a:xfrm>
-          <a:prstGeom prst="rect">
-            <a:avLst/>
-          </a:prstGeom>
-          <a:noFill/>
-          <a:ln/>
-        </p:spPr>
-        <p:txBody>
-          <a:bodyPr wrap="square" lIns="0" tIns="0" rIns="0" bIns="0" rtlCol="0" anchor="ctr"/>
-          <a:lstStyle/>
-          <a:p>
-            <a:pPr algn="ctr" indent="0" marL="0">
-              <a:buNone/>
-            </a:pPr>
-            <a:r>
-              <a:rPr lang="en-US" sz="1100" i="1" dirty="0">
-                <a:solidFill>
-                  <a:srgbClr val="E0D6F0"/>
-                </a:solidFill>
-                <a:latin typeface="Arial" pitchFamily="34" charset="0"/>
-                <a:ea typeface="Arial" pitchFamily="34" charset="-122"/>
-                <a:cs typeface="Arial" pitchFamily="34" charset="-120"/>
-              </a:rPr>
-              <a:t>Use after: Model Building phase</a:t>
-            </a:r>
-            <a:endParaRPr lang="en-US" sz="1100" dirty="0"/>
-          </a:p>
-        </p:txBody>
-      </p:sp>
-      <p:sp>
-        <p:nvSpPr>
-          <p:cNvPr id="5" name="Text 3"/>
-          <p:cNvSpPr/>
-          <p:nvPr/>
-        </p:nvSpPr>
-        <p:spPr>
-          <a:xfrm>
-            <a:off x="548640" y="868680"/>
-            <a:ext cx="11064240" cy="1325880"/>
-          </a:xfrm>
-          <a:prstGeom prst="rect">
-            <a:avLst/>
-          </a:prstGeom>
-          <a:noFill/>
-          <a:ln/>
-        </p:spPr>
-        <p:txBody>
-          <a:bodyPr wrap="square" lIns="0" tIns="0" rIns="0" bIns="0" rtlCol="0" anchor="ctr"/>
-          <a:lstStyle/>
-          <a:p>
-            <a:pPr indent="0" marL="0">
-              <a:buNone/>
-            </a:pPr>
-            <a:r>
-              <a:rPr lang="en-US" sz="2300" b="1" dirty="0">
-                <a:solidFill>
-                  <a:srgbClr val="FFFFFF"/>
-                </a:solidFill>
-                <a:latin typeface="Arial" pitchFamily="34" charset="0"/>
-                <a:ea typeface="Arial" pitchFamily="34" charset="-122"/>
-                <a:cs typeface="Arial" pitchFamily="34" charset="-120"/>
-              </a:rPr>
-              <a:t>A student is revising her model of a kale leaf in a cross-section drawing. Which set of arrows is correct?</a:t>
-            </a:r>
-            <a:endParaRPr lang="en-US" sz="2300" dirty="0"/>
-          </a:p>
-        </p:txBody>
-      </p:sp>
-      <p:sp>
-        <p:nvSpPr>
-          <p:cNvPr id="6" name="Shape 4"/>
-          <p:cNvSpPr/>
-          <p:nvPr/>
-        </p:nvSpPr>
-        <p:spPr>
-          <a:xfrm>
-            <a:off x="731520" y="2331720"/>
-            <a:ext cx="10698480" cy="777240"/>
-          </a:xfrm>
-          <a:prstGeom prst="roundRect">
-            <a:avLst>
-              <a:gd name="adj" fmla="val 9412"/>
-            </a:avLst>
-          </a:prstGeom>
-          <a:solidFill>
-            <a:srgbClr val="7C5CAA"/>
-          </a:solidFill>
-          <a:ln/>
-        </p:spPr>
-      </p:sp>
-      <p:sp>
-        <p:nvSpPr>
-          <p:cNvPr id="7" name="Text 5"/>
-          <p:cNvSpPr/>
-          <p:nvPr/>
-        </p:nvSpPr>
-        <p:spPr>
-          <a:xfrm>
-            <a:off x="914400" y="2331720"/>
-            <a:ext cx="548640" cy="777240"/>
-          </a:xfrm>
-          <a:prstGeom prst="rect">
-            <a:avLst/>
-          </a:prstGeom>
-          <a:noFill/>
-          <a:ln/>
-        </p:spPr>
-        <p:txBody>
-          <a:bodyPr wrap="square" lIns="0" tIns="0" rIns="0" bIns="0" rtlCol="0" anchor="ctr"/>
-          <a:lstStyle/>
-          <a:p>
-            <a:pPr indent="0" marL="0">
-              <a:buNone/>
-            </a:pPr>
-            <a:r>
-              <a:rPr lang="en-US" sz="1800" b="1" dirty="0">
-                <a:solidFill>
-                  <a:srgbClr val="FFFFFF"/>
-                </a:solidFill>
-                <a:latin typeface="Arial" pitchFamily="34" charset="0"/>
-                <a:ea typeface="Arial" pitchFamily="34" charset="-122"/>
-                <a:cs typeface="Arial" pitchFamily="34" charset="-120"/>
-              </a:rPr>
-              <a:t>A</a:t>
-            </a:r>
-            <a:endParaRPr lang="en-US" sz="1800" dirty="0"/>
-          </a:p>
-        </p:txBody>
-      </p:sp>
-      <p:sp>
-        <p:nvSpPr>
-          <p:cNvPr id="8" name="Text 6"/>
-          <p:cNvSpPr/>
-          <p:nvPr/>
-        </p:nvSpPr>
-        <p:spPr>
-          <a:xfrm>
-            <a:off x="1554480" y="2331720"/>
-            <a:ext cx="9692640" cy="777240"/>
-          </a:xfrm>
-          <a:prstGeom prst="rect">
-            <a:avLst/>
-          </a:prstGeom>
-          <a:noFill/>
-          <a:ln/>
-        </p:spPr>
-        <p:txBody>
-          <a:bodyPr wrap="square" lIns="0" tIns="0" rIns="0" bIns="0" rtlCol="0" anchor="ctr"/>
-          <a:lstStyle/>
-          <a:p>
-            <a:pPr indent="0" marL="0">
-              <a:buNone/>
-            </a:pPr>
-            <a:r>
-              <a:rPr lang="en-US" sz="1300" dirty="0">
-                <a:solidFill>
-                  <a:srgbClr val="FFFFFF"/>
-                </a:solidFill>
-                <a:latin typeface="Arial" pitchFamily="34" charset="0"/>
-                <a:ea typeface="Arial" pitchFamily="34" charset="-122"/>
-                <a:cs typeface="Arial" pitchFamily="34" charset="-120"/>
-              </a:rPr>
-              <a:t>Light enters through the stoma, water moves down the xylem, and water vapour leaves through the vascular bundle</a:t>
-            </a:r>
-            <a:endParaRPr lang="en-US" sz="1300" dirty="0"/>
-          </a:p>
-        </p:txBody>
-      </p:sp>
-      <p:sp>
-        <p:nvSpPr>
-          <p:cNvPr id="9" name="Shape 7"/>
-          <p:cNvSpPr/>
-          <p:nvPr/>
-        </p:nvSpPr>
-        <p:spPr>
-          <a:xfrm>
-            <a:off x="731520" y="3246120"/>
-            <a:ext cx="10698480" cy="777240"/>
-          </a:xfrm>
-          <a:prstGeom prst="roundRect">
-            <a:avLst>
-              <a:gd name="adj" fmla="val 9412"/>
-            </a:avLst>
-          </a:prstGeom>
-          <a:solidFill>
-            <a:srgbClr val="7C5CAA"/>
-          </a:solidFill>
-          <a:ln/>
-        </p:spPr>
-      </p:sp>
-      <p:sp>
-        <p:nvSpPr>
-          <p:cNvPr id="10" name="Text 8"/>
-          <p:cNvSpPr/>
-          <p:nvPr/>
-        </p:nvSpPr>
-        <p:spPr>
-          <a:xfrm>
-            <a:off x="914400" y="3246120"/>
-            <a:ext cx="548640" cy="777240"/>
-          </a:xfrm>
-          <a:prstGeom prst="rect">
-            <a:avLst/>
-          </a:prstGeom>
-          <a:noFill/>
-          <a:ln/>
-        </p:spPr>
-        <p:txBody>
-          <a:bodyPr wrap="square" lIns="0" tIns="0" rIns="0" bIns="0" rtlCol="0" anchor="ctr"/>
-          <a:lstStyle/>
-          <a:p>
-            <a:pPr indent="0" marL="0">
-              <a:buNone/>
-            </a:pPr>
-            <a:r>
-              <a:rPr lang="en-US" sz="1800" b="1" dirty="0">
-                <a:solidFill>
-                  <a:srgbClr val="FFFFFF"/>
-                </a:solidFill>
-                <a:latin typeface="Arial" pitchFamily="34" charset="0"/>
-                <a:ea typeface="Arial" pitchFamily="34" charset="-122"/>
-                <a:cs typeface="Arial" pitchFamily="34" charset="-120"/>
-              </a:rPr>
-              <a:t>B</a:t>
-            </a:r>
-            <a:endParaRPr lang="en-US" sz="1800" dirty="0"/>
-          </a:p>
-        </p:txBody>
-      </p:sp>
-      <p:sp>
-        <p:nvSpPr>
-          <p:cNvPr id="11" name="Text 9"/>
-          <p:cNvSpPr/>
-          <p:nvPr/>
-        </p:nvSpPr>
-        <p:spPr>
-          <a:xfrm>
-            <a:off x="1554480" y="3246120"/>
-            <a:ext cx="9692640" cy="777240"/>
-          </a:xfrm>
-          <a:prstGeom prst="rect">
-            <a:avLst/>
-          </a:prstGeom>
-          <a:noFill/>
-          <a:ln/>
-        </p:spPr>
-        <p:txBody>
-          <a:bodyPr wrap="square" lIns="0" tIns="0" rIns="0" bIns="0" rtlCol="0" anchor="ctr"/>
-          <a:lstStyle/>
-          <a:p>
-            <a:pPr indent="0" marL="0">
-              <a:buNone/>
-            </a:pPr>
-            <a:r>
-              <a:rPr lang="en-US" sz="1300" dirty="0">
-                <a:solidFill>
-                  <a:srgbClr val="FFFFFF"/>
-                </a:solidFill>
-                <a:latin typeface="Arial" pitchFamily="34" charset="0"/>
-                <a:ea typeface="Arial" pitchFamily="34" charset="-122"/>
-                <a:cs typeface="Arial" pitchFamily="34" charset="-120"/>
-              </a:rPr>
-              <a:t>Light enters from above through the epidermis, water moves up the xylem, and water vapour leaves through a stoma</a:t>
-            </a:r>
-            <a:endParaRPr lang="en-US" sz="1300" dirty="0"/>
-          </a:p>
-        </p:txBody>
-      </p:sp>
-      <p:sp>
-        <p:nvSpPr>
-          <p:cNvPr id="12" name="Shape 10"/>
-          <p:cNvSpPr/>
-          <p:nvPr/>
-        </p:nvSpPr>
-        <p:spPr>
-          <a:xfrm>
-            <a:off x="731520" y="4160520"/>
-            <a:ext cx="10698480" cy="777240"/>
-          </a:xfrm>
-          <a:prstGeom prst="roundRect">
-            <a:avLst>
-              <a:gd name="adj" fmla="val 9412"/>
-            </a:avLst>
-          </a:prstGeom>
-          <a:solidFill>
-            <a:srgbClr val="7C5CAA"/>
-          </a:solidFill>
-          <a:ln/>
-        </p:spPr>
-      </p:sp>
-      <p:sp>
-        <p:nvSpPr>
-          <p:cNvPr id="13" name="Text 11"/>
-          <p:cNvSpPr/>
-          <p:nvPr/>
-        </p:nvSpPr>
-        <p:spPr>
-          <a:xfrm>
-            <a:off x="914400" y="4160520"/>
-            <a:ext cx="548640" cy="777240"/>
-          </a:xfrm>
-          <a:prstGeom prst="rect">
-            <a:avLst/>
-          </a:prstGeom>
-          <a:noFill/>
-          <a:ln/>
-        </p:spPr>
-        <p:txBody>
-          <a:bodyPr wrap="square" lIns="0" tIns="0" rIns="0" bIns="0" rtlCol="0" anchor="ctr"/>
-          <a:lstStyle/>
-          <a:p>
-            <a:pPr indent="0" marL="0">
-              <a:buNone/>
-            </a:pPr>
-            <a:r>
-              <a:rPr lang="en-US" sz="1800" b="1" dirty="0">
-                <a:solidFill>
-                  <a:srgbClr val="FFFFFF"/>
-                </a:solidFill>
-                <a:latin typeface="Arial" pitchFamily="34" charset="0"/>
-                <a:ea typeface="Arial" pitchFamily="34" charset="-122"/>
-                <a:cs typeface="Arial" pitchFamily="34" charset="-120"/>
-              </a:rPr>
-              <a:t>C</a:t>
-            </a:r>
-            <a:endParaRPr lang="en-US" sz="1800" dirty="0"/>
-          </a:p>
-        </p:txBody>
-      </p:sp>
-      <p:sp>
-        <p:nvSpPr>
-          <p:cNvPr id="14" name="Text 12"/>
-          <p:cNvSpPr/>
-          <p:nvPr/>
-        </p:nvSpPr>
-        <p:spPr>
-          <a:xfrm>
-            <a:off x="1554480" y="4160520"/>
-            <a:ext cx="9692640" cy="777240"/>
-          </a:xfrm>
-          <a:prstGeom prst="rect">
-            <a:avLst/>
-          </a:prstGeom>
-          <a:noFill/>
-          <a:ln/>
-        </p:spPr>
-        <p:txBody>
-          <a:bodyPr wrap="square" lIns="0" tIns="0" rIns="0" bIns="0" rtlCol="0" anchor="ctr"/>
-          <a:lstStyle/>
-          <a:p>
-            <a:pPr indent="0" marL="0">
-              <a:buNone/>
-            </a:pPr>
-            <a:r>
-              <a:rPr lang="en-US" sz="1300" dirty="0">
-                <a:solidFill>
-                  <a:srgbClr val="FFFFFF"/>
-                </a:solidFill>
-                <a:latin typeface="Arial" pitchFamily="34" charset="0"/>
-                <a:ea typeface="Arial" pitchFamily="34" charset="-122"/>
-                <a:cs typeface="Arial" pitchFamily="34" charset="-120"/>
-              </a:rPr>
-              <a:t>Light enters from below, water moves down the phloem, and water vapour enters through the cuticle</a:t>
-            </a:r>
-            <a:endParaRPr lang="en-US" sz="1300" dirty="0"/>
-          </a:p>
-        </p:txBody>
-      </p:sp>
-      <p:sp>
-        <p:nvSpPr>
-          <p:cNvPr id="15" name="Shape 13"/>
-          <p:cNvSpPr/>
-          <p:nvPr/>
-        </p:nvSpPr>
-        <p:spPr>
-          <a:xfrm>
-            <a:off x="731520" y="5074920"/>
-            <a:ext cx="10698480" cy="777240"/>
-          </a:xfrm>
-          <a:prstGeom prst="roundRect">
-            <a:avLst>
-              <a:gd name="adj" fmla="val 9412"/>
-            </a:avLst>
-          </a:prstGeom>
-          <a:solidFill>
-            <a:srgbClr val="7C5CAA"/>
-          </a:solidFill>
-          <a:ln/>
-        </p:spPr>
-      </p:sp>
-      <p:sp>
-        <p:nvSpPr>
-          <p:cNvPr id="16" name="Text 14"/>
-          <p:cNvSpPr/>
-          <p:nvPr/>
-        </p:nvSpPr>
-        <p:spPr>
-          <a:xfrm>
-            <a:off x="914400" y="5074920"/>
-            <a:ext cx="548640" cy="777240"/>
-          </a:xfrm>
-          <a:prstGeom prst="rect">
-            <a:avLst/>
-          </a:prstGeom>
-          <a:noFill/>
-          <a:ln/>
-        </p:spPr>
-        <p:txBody>
-          <a:bodyPr wrap="square" lIns="0" tIns="0" rIns="0" bIns="0" rtlCol="0" anchor="ctr"/>
-          <a:lstStyle/>
-          <a:p>
-            <a:pPr indent="0" marL="0">
-              <a:buNone/>
-            </a:pPr>
-            <a:r>
-              <a:rPr lang="en-US" sz="1800" b="1" dirty="0">
-                <a:solidFill>
-                  <a:srgbClr val="FFFFFF"/>
-                </a:solidFill>
-                <a:latin typeface="Arial" pitchFamily="34" charset="0"/>
-                <a:ea typeface="Arial" pitchFamily="34" charset="-122"/>
-                <a:cs typeface="Arial" pitchFamily="34" charset="-120"/>
-              </a:rPr>
-              <a:t>D</a:t>
-            </a:r>
-            <a:endParaRPr lang="en-US" sz="1800" dirty="0"/>
-          </a:p>
-        </p:txBody>
-      </p:sp>
-      <p:sp>
-        <p:nvSpPr>
-          <p:cNvPr id="17" name="Text 15"/>
-          <p:cNvSpPr/>
-          <p:nvPr/>
-        </p:nvSpPr>
-        <p:spPr>
-          <a:xfrm>
-            <a:off x="1554480" y="5074920"/>
-            <a:ext cx="9692640" cy="777240"/>
-          </a:xfrm>
-          <a:prstGeom prst="rect">
-            <a:avLst/>
-          </a:prstGeom>
-          <a:noFill/>
-          <a:ln/>
-        </p:spPr>
-        <p:txBody>
-          <a:bodyPr wrap="square" lIns="0" tIns="0" rIns="0" bIns="0" rtlCol="0" anchor="ctr"/>
-          <a:lstStyle/>
-          <a:p>
-            <a:pPr indent="0" marL="0">
-              <a:buNone/>
-            </a:pPr>
-            <a:r>
-              <a:rPr lang="en-US" sz="1300" dirty="0">
-                <a:solidFill>
-                  <a:srgbClr val="FFFFFF"/>
-                </a:solidFill>
-                <a:latin typeface="Arial" pitchFamily="34" charset="0"/>
-                <a:ea typeface="Arial" pitchFamily="34" charset="-122"/>
-                <a:cs typeface="Arial" pitchFamily="34" charset="-120"/>
-              </a:rPr>
-              <a:t>Light enters from above, sugars move up the xylem, and water vapour leaves through the palisade cells</a:t>
-            </a:r>
-            <a:endParaRPr lang="en-US" sz="1300" dirty="0"/>
-          </a:p>
-        </p:txBody>
-      </p:sp>
-      <p:sp>
-        <p:nvSpPr>
-          <p:cNvPr id="18" name="Text 16"/>
-          <p:cNvSpPr/>
-          <p:nvPr/>
-        </p:nvSpPr>
-        <p:spPr>
-          <a:xfrm>
-            <a:off x="11521440" y="6446520"/>
-            <a:ext cx="457200" cy="274320"/>
-          </a:xfrm>
-          <a:prstGeom prst="rect">
-            <a:avLst/>
-          </a:prstGeom>
-          <a:noFill/>
-          <a:ln/>
-        </p:spPr>
-        <p:txBody>
-          <a:bodyPr wrap="square" lIns="0" tIns="0" rIns="0" bIns="0" rtlCol="0" anchor="ctr"/>
-          <a:lstStyle/>
-          <a:p>
-            <a:pPr algn="r" indent="0" marL="0">
-              <a:buNone/>
-            </a:pPr>
-            <a:r>
-              <a:rPr lang="en-US" sz="1000" dirty="0">
-                <a:solidFill>
-                  <a:srgbClr val="C9B8E0"/>
-                </a:solidFill>
-                <a:latin typeface="Arial" pitchFamily="34" charset="0"/>
-                <a:ea typeface="Arial" pitchFamily="34" charset="-122"/>
-                <a:cs typeface="Arial" pitchFamily="34" charset="-120"/>
-              </a:rPr>
-              <a:t>10</a:t>
-            </a:r>
-            <a:endParaRPr lang="en-US" sz="1000" dirty="0"/>
-          </a:p>
-        </p:txBody>
-      </p:sp>
-    </p:spTree>
-  </p:cSld>
-  <p:clrMapOvr>
-    <a:masterClrMapping/>
-  </p:clrMapOvr>
-</p:sld>
-</file>
-
-<file path=ppt/slides/slide11.xml><?xml version="1.0" encoding="utf-8"?>
-<p:sld xmlns:a="http://schemas.openxmlformats.org/drawingml/2006/main" xmlns:r="http://schemas.openxmlformats.org/officeDocument/2006/relationships" xmlns:p="http://schemas.openxmlformats.org/presentationml/2006/main">
-  <p:cSld name="Slide 11">
-    <p:bg>
-      <p:bgPr>
-        <a:solidFill>
-          <a:srgbClr val="6A4C93"/>
-        </a:solidFill>
-      </p:bgPr>
-    </p:bg>
-    <p:spTree>
-      <p:nvGrpSpPr>
-        <p:cNvPr id="1" name=""/>
-        <p:cNvGrpSpPr/>
-        <p:nvPr/>
-      </p:nvGrpSpPr>
-      <p:grpSpPr>
-        <a:xfrm>
-          <a:off x="0" y="0"/>
-          <a:ext cx="0" cy="0"/>
-          <a:chOff x="0" y="0"/>
-          <a:chExt cx="0" cy="0"/>
-        </a:xfrm>
-      </p:grpSpPr>
-      <p:sp>
-        <p:nvSpPr>
-          <p:cNvPr id="2" name="Text 0"/>
-          <p:cNvSpPr/>
-          <p:nvPr/>
-        </p:nvSpPr>
-        <p:spPr>
-          <a:xfrm>
-            <a:off x="548640" y="365760"/>
-            <a:ext cx="6400800" cy="365760"/>
-          </a:xfrm>
-          <a:prstGeom prst="rect">
-            <a:avLst/>
-          </a:prstGeom>
-          <a:noFill/>
-          <a:ln/>
-        </p:spPr>
-        <p:txBody>
-          <a:bodyPr wrap="square" lIns="0" tIns="0" rIns="0" bIns="0" rtlCol="0" anchor="ctr"/>
-          <a:lstStyle/>
-          <a:p>
-            <a:pPr indent="0" marL="0">
-              <a:buNone/>
-            </a:pPr>
-            <a:r>
-              <a:rPr lang="en-US" sz="1300" b="1" spc="200" kern="0" dirty="0">
-                <a:solidFill>
-                  <a:srgbClr val="E0D6F0"/>
-                </a:solidFill>
-                <a:latin typeface="Arial" pitchFamily="34" charset="0"/>
-                <a:ea typeface="Arial" pitchFamily="34" charset="-122"/>
-                <a:cs typeface="Arial" pitchFamily="34" charset="-120"/>
-              </a:rPr>
-              <a:t>QUESTION 10 OF 10</a:t>
-            </a:r>
-            <a:endParaRPr lang="en-US" sz="1300" dirty="0"/>
-          </a:p>
-        </p:txBody>
-      </p:sp>
-      <p:sp>
-        <p:nvSpPr>
-          <p:cNvPr id="3" name="Shape 1"/>
-          <p:cNvSpPr/>
-          <p:nvPr/>
-        </p:nvSpPr>
-        <p:spPr>
-          <a:xfrm>
-            <a:off x="8138160" y="320040"/>
-            <a:ext cx="3474720" cy="365760"/>
-          </a:xfrm>
-          <a:prstGeom prst="roundRect">
-            <a:avLst>
-              <a:gd name="adj" fmla="val 15000"/>
-            </a:avLst>
-          </a:prstGeom>
-          <a:solidFill>
-            <a:srgbClr val="5A3F80"/>
-          </a:solidFill>
-          <a:ln/>
-        </p:spPr>
-      </p:sp>
-      <p:sp>
-        <p:nvSpPr>
-          <p:cNvPr id="4" name="Text 2"/>
-          <p:cNvSpPr/>
-          <p:nvPr/>
-        </p:nvSpPr>
-        <p:spPr>
-          <a:xfrm>
-            <a:off x="8138160" y="320040"/>
-            <a:ext cx="3474720" cy="365760"/>
-          </a:xfrm>
-          <a:prstGeom prst="rect">
-            <a:avLst/>
-          </a:prstGeom>
-          <a:noFill/>
-          <a:ln/>
-        </p:spPr>
-        <p:txBody>
-          <a:bodyPr wrap="square" lIns="0" tIns="0" rIns="0" bIns="0" rtlCol="0" anchor="ctr"/>
-          <a:lstStyle/>
-          <a:p>
-            <a:pPr algn="ctr" indent="0" marL="0">
-              <a:buNone/>
-            </a:pPr>
-            <a:r>
-              <a:rPr lang="en-US" sz="1100" i="1" dirty="0">
-                <a:solidFill>
-                  <a:srgbClr val="E0D6F0"/>
-                </a:solidFill>
-                <a:latin typeface="Arial" pitchFamily="34" charset="0"/>
-                <a:ea typeface="Arial" pitchFamily="34" charset="-122"/>
-                <a:cs typeface="Arial" pitchFamily="34" charset="-120"/>
-              </a:rPr>
-              <a:t>Use after: DQB phase</a:t>
-            </a:r>
-            <a:endParaRPr lang="en-US" sz="1100" dirty="0"/>
-          </a:p>
-        </p:txBody>
-      </p:sp>
-      <p:sp>
-        <p:nvSpPr>
-          <p:cNvPr id="5" name="Text 3"/>
-          <p:cNvSpPr/>
-          <p:nvPr/>
-        </p:nvSpPr>
-        <p:spPr>
-          <a:xfrm>
-            <a:off x="548640" y="868680"/>
-            <a:ext cx="11064240" cy="1325880"/>
-          </a:xfrm>
-          <a:prstGeom prst="rect">
-            <a:avLst/>
-          </a:prstGeom>
-          <a:noFill/>
-          <a:ln/>
-        </p:spPr>
-        <p:txBody>
-          <a:bodyPr wrap="square" lIns="0" tIns="0" rIns="0" bIns="0" rtlCol="0" anchor="ctr"/>
-          <a:lstStyle/>
-          <a:p>
-            <a:pPr indent="0" marL="0">
-              <a:buNone/>
-            </a:pPr>
-            <a:r>
-              <a:rPr lang="en-US" sz="2000" b="1" dirty="0">
-                <a:solidFill>
-                  <a:srgbClr val="FFFFFF"/>
-                </a:solidFill>
-                <a:latin typeface="Arial" pitchFamily="34" charset="0"/>
-                <a:ea typeface="Arial" pitchFamily="34" charset="-122"/>
-                <a:cs typeface="Arial" pitchFamily="34" charset="-120"/>
-              </a:rPr>
-              <a:t>After observing a leaf cross-section, which Driving Question Board question could students already partly answer using today's evidence?</a:t>
-            </a:r>
-            <a:endParaRPr lang="en-US" sz="2000" dirty="0"/>
-          </a:p>
-        </p:txBody>
-      </p:sp>
-      <p:sp>
-        <p:nvSpPr>
-          <p:cNvPr id="6" name="Shape 4"/>
-          <p:cNvSpPr/>
-          <p:nvPr/>
-        </p:nvSpPr>
-        <p:spPr>
-          <a:xfrm>
-            <a:off x="731520" y="2331720"/>
-            <a:ext cx="10698480" cy="777240"/>
-          </a:xfrm>
-          <a:prstGeom prst="roundRect">
-            <a:avLst>
-              <a:gd name="adj" fmla="val 9412"/>
-            </a:avLst>
-          </a:prstGeom>
-          <a:solidFill>
-            <a:srgbClr val="7C5CAA"/>
-          </a:solidFill>
-          <a:ln/>
-        </p:spPr>
-      </p:sp>
-      <p:sp>
-        <p:nvSpPr>
-          <p:cNvPr id="7" name="Text 5"/>
-          <p:cNvSpPr/>
-          <p:nvPr/>
-        </p:nvSpPr>
-        <p:spPr>
-          <a:xfrm>
-            <a:off x="914400" y="2331720"/>
-            <a:ext cx="548640" cy="777240"/>
-          </a:xfrm>
-          <a:prstGeom prst="rect">
-            <a:avLst/>
-          </a:prstGeom>
-          <a:noFill/>
-          <a:ln/>
-        </p:spPr>
-        <p:txBody>
-          <a:bodyPr wrap="square" lIns="0" tIns="0" rIns="0" bIns="0" rtlCol="0" anchor="ctr"/>
-          <a:lstStyle/>
-          <a:p>
-            <a:pPr indent="0" marL="0">
-              <a:buNone/>
-            </a:pPr>
-            <a:r>
-              <a:rPr lang="en-US" sz="1800" b="1" dirty="0">
-                <a:solidFill>
-                  <a:srgbClr val="FFFFFF"/>
-                </a:solidFill>
-                <a:latin typeface="Arial" pitchFamily="34" charset="0"/>
-                <a:ea typeface="Arial" pitchFamily="34" charset="-122"/>
-                <a:cs typeface="Arial" pitchFamily="34" charset="-120"/>
-              </a:rPr>
-              <a:t>A</a:t>
-            </a:r>
-            <a:endParaRPr lang="en-US" sz="1800" dirty="0"/>
-          </a:p>
-        </p:txBody>
-      </p:sp>
-      <p:sp>
-        <p:nvSpPr>
-          <p:cNvPr id="8" name="Text 6"/>
-          <p:cNvSpPr/>
-          <p:nvPr/>
-        </p:nvSpPr>
-        <p:spPr>
-          <a:xfrm>
-            <a:off x="1554480" y="2331720"/>
-            <a:ext cx="9692640" cy="777240"/>
-          </a:xfrm>
-          <a:prstGeom prst="rect">
-            <a:avLst/>
-          </a:prstGeom>
-          <a:noFill/>
-          <a:ln/>
-        </p:spPr>
-        <p:txBody>
-          <a:bodyPr wrap="square" lIns="0" tIns="0" rIns="0" bIns="0" rtlCol="0" anchor="ctr"/>
-          <a:lstStyle/>
-          <a:p>
-            <a:pPr indent="0" marL="0">
-              <a:buNone/>
-            </a:pPr>
-            <a:r>
-              <a:rPr lang="en-US" sz="1700" dirty="0">
-                <a:solidFill>
-                  <a:srgbClr val="FFFFFF"/>
-                </a:solidFill>
-                <a:latin typeface="Arial" pitchFamily="34" charset="0"/>
-                <a:ea typeface="Arial" pitchFamily="34" charset="-122"/>
-                <a:cs typeface="Arial" pitchFamily="34" charset="-120"/>
-              </a:rPr>
-              <a:t>Why do sukuma wiki leaves wilt at midday even when the soil is moist?</a:t>
-            </a:r>
-            <a:endParaRPr lang="en-US" sz="1700" dirty="0"/>
-          </a:p>
-        </p:txBody>
-      </p:sp>
-      <p:sp>
-        <p:nvSpPr>
-          <p:cNvPr id="9" name="Shape 7"/>
-          <p:cNvSpPr/>
-          <p:nvPr/>
-        </p:nvSpPr>
-        <p:spPr>
-          <a:xfrm>
-            <a:off x="731520" y="3246120"/>
-            <a:ext cx="10698480" cy="777240"/>
-          </a:xfrm>
-          <a:prstGeom prst="roundRect">
-            <a:avLst>
-              <a:gd name="adj" fmla="val 9412"/>
-            </a:avLst>
-          </a:prstGeom>
-          <a:solidFill>
-            <a:srgbClr val="7C5CAA"/>
-          </a:solidFill>
-          <a:ln/>
-        </p:spPr>
-      </p:sp>
-      <p:sp>
-        <p:nvSpPr>
-          <p:cNvPr id="10" name="Text 8"/>
-          <p:cNvSpPr/>
-          <p:nvPr/>
-        </p:nvSpPr>
-        <p:spPr>
-          <a:xfrm>
-            <a:off x="914400" y="3246120"/>
-            <a:ext cx="548640" cy="777240"/>
-          </a:xfrm>
-          <a:prstGeom prst="rect">
-            <a:avLst/>
-          </a:prstGeom>
-          <a:noFill/>
-          <a:ln/>
-        </p:spPr>
-        <p:txBody>
-          <a:bodyPr wrap="square" lIns="0" tIns="0" rIns="0" bIns="0" rtlCol="0" anchor="ctr"/>
-          <a:lstStyle/>
-          <a:p>
-            <a:pPr indent="0" marL="0">
-              <a:buNone/>
-            </a:pPr>
-            <a:r>
-              <a:rPr lang="en-US" sz="1800" b="1" dirty="0">
-                <a:solidFill>
-                  <a:srgbClr val="FFFFFF"/>
-                </a:solidFill>
-                <a:latin typeface="Arial" pitchFamily="34" charset="0"/>
-                <a:ea typeface="Arial" pitchFamily="34" charset="-122"/>
-                <a:cs typeface="Arial" pitchFamily="34" charset="-120"/>
-              </a:rPr>
-              <a:t>B</a:t>
-            </a:r>
-            <a:endParaRPr lang="en-US" sz="1800" dirty="0"/>
-          </a:p>
-        </p:txBody>
-      </p:sp>
-      <p:sp>
-        <p:nvSpPr>
-          <p:cNvPr id="11" name="Text 9"/>
-          <p:cNvSpPr/>
-          <p:nvPr/>
-        </p:nvSpPr>
-        <p:spPr>
-          <a:xfrm>
-            <a:off x="1554480" y="3246120"/>
-            <a:ext cx="9692640" cy="777240"/>
-          </a:xfrm>
-          <a:prstGeom prst="rect">
-            <a:avLst/>
-          </a:prstGeom>
-          <a:noFill/>
-          <a:ln/>
-        </p:spPr>
-        <p:txBody>
-          <a:bodyPr wrap="square" lIns="0" tIns="0" rIns="0" bIns="0" rtlCol="0" anchor="ctr"/>
-          <a:lstStyle/>
-          <a:p>
-            <a:pPr indent="0" marL="0">
-              <a:buNone/>
-            </a:pPr>
-            <a:r>
-              <a:rPr lang="en-US" sz="1700" dirty="0">
-                <a:solidFill>
-                  <a:srgbClr val="FFFFFF"/>
-                </a:solidFill>
-                <a:latin typeface="Arial" pitchFamily="34" charset="0"/>
-                <a:ea typeface="Arial" pitchFamily="34" charset="-122"/>
-                <a:cs typeface="Arial" pitchFamily="34" charset="-120"/>
-              </a:rPr>
-              <a:t>What exactly makes the guard cells open the stoma?</a:t>
-            </a:r>
-            <a:endParaRPr lang="en-US" sz="1700" dirty="0"/>
-          </a:p>
-        </p:txBody>
-      </p:sp>
-      <p:sp>
-        <p:nvSpPr>
-          <p:cNvPr id="12" name="Shape 10"/>
-          <p:cNvSpPr/>
-          <p:nvPr/>
-        </p:nvSpPr>
-        <p:spPr>
-          <a:xfrm>
-            <a:off x="731520" y="4160520"/>
-            <a:ext cx="10698480" cy="777240"/>
-          </a:xfrm>
-          <a:prstGeom prst="roundRect">
-            <a:avLst>
-              <a:gd name="adj" fmla="val 9412"/>
-            </a:avLst>
-          </a:prstGeom>
-          <a:solidFill>
-            <a:srgbClr val="7C5CAA"/>
-          </a:solidFill>
-          <a:ln/>
-        </p:spPr>
-      </p:sp>
-      <p:sp>
-        <p:nvSpPr>
-          <p:cNvPr id="13" name="Text 11"/>
-          <p:cNvSpPr/>
-          <p:nvPr/>
-        </p:nvSpPr>
-        <p:spPr>
-          <a:xfrm>
-            <a:off x="914400" y="4160520"/>
-            <a:ext cx="548640" cy="777240"/>
-          </a:xfrm>
-          <a:prstGeom prst="rect">
-            <a:avLst/>
-          </a:prstGeom>
-          <a:noFill/>
-          <a:ln/>
-        </p:spPr>
-        <p:txBody>
-          <a:bodyPr wrap="square" lIns="0" tIns="0" rIns="0" bIns="0" rtlCol="0" anchor="ctr"/>
-          <a:lstStyle/>
-          <a:p>
-            <a:pPr indent="0" marL="0">
-              <a:buNone/>
-            </a:pPr>
-            <a:r>
-              <a:rPr lang="en-US" sz="1800" b="1" dirty="0">
-                <a:solidFill>
-                  <a:srgbClr val="FFFFFF"/>
-                </a:solidFill>
-                <a:latin typeface="Arial" pitchFamily="34" charset="0"/>
-                <a:ea typeface="Arial" pitchFamily="34" charset="-122"/>
-                <a:cs typeface="Arial" pitchFamily="34" charset="-120"/>
-              </a:rPr>
-              <a:t>C</a:t>
-            </a:r>
-            <a:endParaRPr lang="en-US" sz="1800" dirty="0"/>
-          </a:p>
-        </p:txBody>
-      </p:sp>
-      <p:sp>
-        <p:nvSpPr>
-          <p:cNvPr id="14" name="Text 12"/>
-          <p:cNvSpPr/>
-          <p:nvPr/>
-        </p:nvSpPr>
-        <p:spPr>
-          <a:xfrm>
-            <a:off x="1554480" y="4160520"/>
-            <a:ext cx="9692640" cy="777240"/>
-          </a:xfrm>
-          <a:prstGeom prst="rect">
-            <a:avLst/>
-          </a:prstGeom>
-          <a:noFill/>
-          <a:ln/>
-        </p:spPr>
-        <p:txBody>
-          <a:bodyPr wrap="square" lIns="0" tIns="0" rIns="0" bIns="0" rtlCol="0" anchor="ctr"/>
-          <a:lstStyle/>
-          <a:p>
-            <a:pPr indent="0" marL="0">
-              <a:buNone/>
-            </a:pPr>
-            <a:r>
-              <a:rPr lang="en-US" sz="1700" dirty="0">
-                <a:solidFill>
-                  <a:srgbClr val="FFFFFF"/>
-                </a:solidFill>
-                <a:latin typeface="Arial" pitchFamily="34" charset="0"/>
-                <a:ea typeface="Arial" pitchFamily="34" charset="-122"/>
-                <a:cs typeface="Arial" pitchFamily="34" charset="-120"/>
-              </a:rPr>
-              <a:t>Why are leaves green?</a:t>
-            </a:r>
-            <a:endParaRPr lang="en-US" sz="1700" dirty="0"/>
-          </a:p>
-        </p:txBody>
-      </p:sp>
-      <p:sp>
-        <p:nvSpPr>
-          <p:cNvPr id="15" name="Shape 13"/>
-          <p:cNvSpPr/>
-          <p:nvPr/>
-        </p:nvSpPr>
-        <p:spPr>
-          <a:xfrm>
-            <a:off x="731520" y="5074920"/>
-            <a:ext cx="10698480" cy="777240"/>
-          </a:xfrm>
-          <a:prstGeom prst="roundRect">
-            <a:avLst>
-              <a:gd name="adj" fmla="val 9412"/>
-            </a:avLst>
-          </a:prstGeom>
-          <a:solidFill>
-            <a:srgbClr val="7C5CAA"/>
-          </a:solidFill>
-          <a:ln/>
-        </p:spPr>
-      </p:sp>
-      <p:sp>
-        <p:nvSpPr>
-          <p:cNvPr id="16" name="Text 14"/>
-          <p:cNvSpPr/>
-          <p:nvPr/>
-        </p:nvSpPr>
-        <p:spPr>
-          <a:xfrm>
-            <a:off x="914400" y="5074920"/>
-            <a:ext cx="548640" cy="777240"/>
-          </a:xfrm>
-          <a:prstGeom prst="rect">
-            <a:avLst/>
-          </a:prstGeom>
-          <a:noFill/>
-          <a:ln/>
-        </p:spPr>
-        <p:txBody>
-          <a:bodyPr wrap="square" lIns="0" tIns="0" rIns="0" bIns="0" rtlCol="0" anchor="ctr"/>
-          <a:lstStyle/>
-          <a:p>
-            <a:pPr indent="0" marL="0">
-              <a:buNone/>
-            </a:pPr>
-            <a:r>
-              <a:rPr lang="en-US" sz="1800" b="1" dirty="0">
-                <a:solidFill>
-                  <a:srgbClr val="FFFFFF"/>
-                </a:solidFill>
-                <a:latin typeface="Arial" pitchFamily="34" charset="0"/>
-                <a:ea typeface="Arial" pitchFamily="34" charset="-122"/>
-                <a:cs typeface="Arial" pitchFamily="34" charset="-120"/>
-              </a:rPr>
-              <a:t>D</a:t>
-            </a:r>
-            <a:endParaRPr lang="en-US" sz="1800" dirty="0"/>
-          </a:p>
-        </p:txBody>
-      </p:sp>
-      <p:sp>
-        <p:nvSpPr>
-          <p:cNvPr id="17" name="Text 15"/>
-          <p:cNvSpPr/>
-          <p:nvPr/>
-        </p:nvSpPr>
-        <p:spPr>
-          <a:xfrm>
-            <a:off x="1554480" y="5074920"/>
-            <a:ext cx="9692640" cy="777240"/>
-          </a:xfrm>
-          <a:prstGeom prst="rect">
-            <a:avLst/>
-          </a:prstGeom>
-          <a:noFill/>
-          <a:ln/>
-        </p:spPr>
-        <p:txBody>
-          <a:bodyPr wrap="square" lIns="0" tIns="0" rIns="0" bIns="0" rtlCol="0" anchor="ctr"/>
-          <a:lstStyle/>
-          <a:p>
-            <a:pPr indent="0" marL="0">
-              <a:buNone/>
-            </a:pPr>
-            <a:r>
-              <a:rPr lang="en-US" sz="1700" dirty="0">
-                <a:solidFill>
-                  <a:srgbClr val="FFFFFF"/>
-                </a:solidFill>
-                <a:latin typeface="Arial" pitchFamily="34" charset="0"/>
-                <a:ea typeface="Arial" pitchFamily="34" charset="-122"/>
-                <a:cs typeface="Arial" pitchFamily="34" charset="-120"/>
-              </a:rPr>
-              <a:t>What is the full chemical equation for photosynthesis?</a:t>
-            </a:r>
-            <a:endParaRPr lang="en-US" sz="1700" dirty="0"/>
-          </a:p>
-        </p:txBody>
-      </p:sp>
-      <p:sp>
-        <p:nvSpPr>
-          <p:cNvPr id="18" name="Text 16"/>
-          <p:cNvSpPr/>
-          <p:nvPr/>
-        </p:nvSpPr>
-        <p:spPr>
-          <a:xfrm>
-            <a:off x="11521440" y="6446520"/>
-            <a:ext cx="457200" cy="274320"/>
-          </a:xfrm>
-          <a:prstGeom prst="rect">
-            <a:avLst/>
-          </a:prstGeom>
-          <a:noFill/>
-          <a:ln/>
-        </p:spPr>
-        <p:txBody>
-          <a:bodyPr wrap="square" lIns="0" tIns="0" rIns="0" bIns="0" rtlCol="0" anchor="ctr"/>
-          <a:lstStyle/>
-          <a:p>
-            <a:pPr algn="r" indent="0" marL="0">
-              <a:buNone/>
-            </a:pPr>
-            <a:r>
-              <a:rPr lang="en-US" sz="1000" dirty="0">
-                <a:solidFill>
-                  <a:srgbClr val="C9B8E0"/>
-                </a:solidFill>
-                <a:latin typeface="Arial" pitchFamily="34" charset="0"/>
-                <a:ea typeface="Arial" pitchFamily="34" charset="-122"/>
-                <a:cs typeface="Arial" pitchFamily="34" charset="-120"/>
-              </a:rPr>
-              <a:t>11</a:t>
-            </a:r>
-            <a:endParaRPr lang="en-US" sz="1000" dirty="0"/>
-          </a:p>
-        </p:txBody>
-      </p:sp>
-    </p:spTree>
-  </p:cSld>
-  <p:clrMapOvr>
-    <a:masterClrMapping/>
-  </p:clrMapOvr>
-</p:sld>
-</file>
-
-<file path=ppt/slides/slide12.xml><?xml version="1.0" encoding="utf-8"?>
-<p:sld xmlns:a="http://schemas.openxmlformats.org/drawingml/2006/main" xmlns:r="http://schemas.openxmlformats.org/officeDocument/2006/relationships" xmlns:p="http://schemas.openxmlformats.org/presentationml/2006/main">
-  <p:cSld name="Slide 12">
-    <p:bg>
-      <p:bgPr>
-        <a:solidFill>
-          <a:srgbClr val="1F3864"/>
-        </a:solidFill>
-      </p:bgPr>
-    </p:bg>
-    <p:spTree>
-      <p:nvGrpSpPr>
-        <p:cNvPr id="1" name=""/>
-        <p:cNvGrpSpPr/>
-        <p:nvPr/>
-      </p:nvGrpSpPr>
-      <p:grpSpPr>
-        <a:xfrm>
-          <a:off x="0" y="0"/>
-          <a:ext cx="0" cy="0"/>
-          <a:chOff x="0" y="0"/>
-          <a:chExt cx="0" cy="0"/>
-        </a:xfrm>
-      </p:grpSpPr>
-      <p:sp>
-        <p:nvSpPr>
-          <p:cNvPr id="2" name="Text 0"/>
-          <p:cNvSpPr/>
-          <p:nvPr/>
-        </p:nvSpPr>
-        <p:spPr>
-          <a:xfrm>
-            <a:off x="731520" y="2194560"/>
-            <a:ext cx="10698480" cy="822960"/>
-          </a:xfrm>
-          <a:prstGeom prst="rect">
-            <a:avLst/>
-          </a:prstGeom>
-          <a:noFill/>
-          <a:ln/>
-        </p:spPr>
-        <p:txBody>
-          <a:bodyPr wrap="square" lIns="0" tIns="0" rIns="0" bIns="0" rtlCol="0" anchor="ctr"/>
-          <a:lstStyle/>
-          <a:p>
-            <a:pPr indent="0" marL="0">
-              <a:buNone/>
-            </a:pPr>
-            <a:r>
-              <a:rPr lang="en-US" sz="3400" b="1" dirty="0">
-                <a:solidFill>
-                  <a:srgbClr val="FFFFFF"/>
-                </a:solidFill>
-                <a:latin typeface="Arial" pitchFamily="34" charset="0"/>
-                <a:ea typeface="Arial" pitchFamily="34" charset="-122"/>
-                <a:cs typeface="Arial" pitchFamily="34" charset="-120"/>
-              </a:rPr>
-              <a:t>All done</a:t>
-            </a:r>
-            <a:endParaRPr lang="en-US" sz="3400" dirty="0"/>
-          </a:p>
-        </p:txBody>
-      </p:sp>
-      <p:sp>
-        <p:nvSpPr>
-          <p:cNvPr id="3" name="Text 1"/>
-          <p:cNvSpPr/>
-          <p:nvPr/>
-        </p:nvSpPr>
-        <p:spPr>
-          <a:xfrm>
-            <a:off x="731520" y="3108960"/>
-            <a:ext cx="10698480" cy="731520"/>
-          </a:xfrm>
-          <a:prstGeom prst="rect">
-            <a:avLst/>
-          </a:prstGeom>
-          <a:noFill/>
-          <a:ln/>
-        </p:spPr>
-        <p:txBody>
-          <a:bodyPr wrap="square" lIns="0" tIns="0" rIns="0" bIns="0" rtlCol="0" anchor="ctr"/>
-          <a:lstStyle/>
-          <a:p>
-            <a:pPr indent="0" marL="0">
-              <a:buNone/>
-            </a:pPr>
-            <a:r>
-              <a:rPr lang="en-US" sz="1800" dirty="0">
-                <a:solidFill>
-                  <a:srgbClr val="D9EEF1"/>
-                </a:solidFill>
-                <a:latin typeface="Arial" pitchFamily="34" charset="0"/>
-                <a:ea typeface="Arial" pitchFamily="34" charset="-122"/>
-                <a:cs typeface="Arial" pitchFamily="34" charset="-120"/>
-              </a:rPr>
-              <a:t>Ask your teacher how to submit your answers today (for example, on a paper answer slip).</a:t>
-            </a:r>
-            <a:endParaRPr lang="en-US" sz="1800" dirty="0"/>
           </a:p>
         </p:txBody>
       </p:sp>
@@ -3518,7 +1921,7 @@
                 <a:ea typeface="Arial" pitchFamily="34" charset="-122"/>
                 <a:cs typeface="Arial" pitchFamily="34" charset="-120"/>
               </a:rPr>
-              <a:t>QUESTION 1 OF 10</a:t>
+              <a:t>QUESTION 1 OF 7</a:t>
             </a:r>
             <a:endParaRPr lang="en-US" sz="1300" dirty="0"/>
           </a:p>
@@ -3579,7 +1982,7 @@
                 <a:ea typeface="Arial" pitchFamily="34" charset="-122"/>
                 <a:cs typeface="Arial" pitchFamily="34" charset="-120"/>
               </a:rPr>
-              <a:t>Use after: Observe phase</a:t>
+              <a:t>Use after: Explain phase</a:t>
             </a:r>
             <a:endParaRPr lang="en-US" sz="1100" dirty="0"/>
           </a:p>
@@ -3618,7 +2021,7 @@
                 <a:ea typeface="Arial" pitchFamily="34" charset="-122"/>
                 <a:cs typeface="Arial" pitchFamily="34" charset="-120"/>
               </a:rPr>
-              <a:t>You are looking at a cross-section of a mango leaf. On which layer would you find most of the stomata, with a pair of guard cells around each one?</a:t>
+              <a:t>In a cross-section of a mango leaf, which layer has tall cells packed closely together just beneath the upper epidermis, each holding many chloroplasts?</a:t>
             </a:r>
             <a:endParaRPr lang="en-US" sz="2000" dirty="0"/>
           </a:p>
@@ -3718,7 +2121,7 @@
                 <a:ea typeface="Arial" pitchFamily="34" charset="-122"/>
                 <a:cs typeface="Arial" pitchFamily="34" charset="-120"/>
               </a:rPr>
-              <a:t>The palisade mesophyll</a:t>
+              <a:t>Palisade mesophyll</a:t>
             </a:r>
             <a:endParaRPr lang="en-US" sz="1700" dirty="0"/>
           </a:p>
@@ -3818,7 +2221,7 @@
                 <a:ea typeface="Arial" pitchFamily="34" charset="-122"/>
                 <a:cs typeface="Arial" pitchFamily="34" charset="-120"/>
               </a:rPr>
-              <a:t>The waxy cuticle on the upper surface</a:t>
+              <a:t>Vascular bundle</a:t>
             </a:r>
             <a:endParaRPr lang="en-US" sz="1700" dirty="0"/>
           </a:p>
@@ -3918,7 +2321,7 @@
                 <a:ea typeface="Arial" pitchFamily="34" charset="-122"/>
                 <a:cs typeface="Arial" pitchFamily="34" charset="-120"/>
               </a:rPr>
-              <a:t>The xylem in the vascular bundle</a:t>
+              <a:t>Lower epidermis</a:t>
             </a:r>
             <a:endParaRPr lang="en-US" sz="1700" dirty="0"/>
           </a:p>
@@ -4018,7 +2421,7 @@
                 <a:ea typeface="Arial" pitchFamily="34" charset="-122"/>
                 <a:cs typeface="Arial" pitchFamily="34" charset="-120"/>
               </a:rPr>
-              <a:t>The lower epidermis</a:t>
+              <a:t>Spongy mesophyll</a:t>
             </a:r>
             <a:endParaRPr lang="en-US" sz="1700" dirty="0"/>
           </a:p>
@@ -4128,7 +2531,7 @@
                 <a:ea typeface="Arial" pitchFamily="34" charset="-122"/>
                 <a:cs typeface="Arial" pitchFamily="34" charset="-120"/>
               </a:rPr>
-              <a:t>QUESTION 2 OF 10</a:t>
+              <a:t>QUESTION 2 OF 7</a:t>
             </a:r>
             <a:endParaRPr lang="en-US" sz="1300" dirty="0"/>
           </a:p>
@@ -4228,7 +2631,7 @@
                 <a:ea typeface="Arial" pitchFamily="34" charset="-122"/>
                 <a:cs typeface="Arial" pitchFamily="34" charset="-120"/>
               </a:rPr>
-              <a:t>In a leaf cross-section, which layer sits just below the upper epidermis and is made of tightly packed, column-shaped cells full of chloroplasts?</a:t>
+              <a:t>A student examines a mango leaf cross-section under a microscope and looks for stomata with guard cells. Where will she find most of them?</a:t>
             </a:r>
             <a:endParaRPr lang="en-US" sz="2000" dirty="0"/>
           </a:p>
@@ -4328,7 +2731,7 @@
                 <a:ea typeface="Arial" pitchFamily="34" charset="-122"/>
                 <a:cs typeface="Arial" pitchFamily="34" charset="-120"/>
               </a:rPr>
-              <a:t>Lower epidermis</a:t>
+              <a:t>In the lower epidermis</a:t>
             </a:r>
             <a:endParaRPr lang="en-US" sz="1700" dirty="0"/>
           </a:p>
@@ -4428,7 +2831,7 @@
                 <a:ea typeface="Arial" pitchFamily="34" charset="-122"/>
                 <a:cs typeface="Arial" pitchFamily="34" charset="-120"/>
               </a:rPr>
-              <a:t>Spongy mesophyll</a:t>
+              <a:t>In the upper epidermis, where the sun is strongest</a:t>
             </a:r>
             <a:endParaRPr lang="en-US" sz="1700" dirty="0"/>
           </a:p>
@@ -4528,7 +2931,7 @@
                 <a:ea typeface="Arial" pitchFamily="34" charset="-122"/>
                 <a:cs typeface="Arial" pitchFamily="34" charset="-120"/>
               </a:rPr>
-              <a:t>Palisade mesophyll</a:t>
+              <a:t>Inside the palisade mesophyll layer</a:t>
             </a:r>
             <a:endParaRPr lang="en-US" sz="1700" dirty="0"/>
           </a:p>
@@ -4628,7 +3031,7 @@
                 <a:ea typeface="Arial" pitchFamily="34" charset="-122"/>
                 <a:cs typeface="Arial" pitchFamily="34" charset="-120"/>
               </a:rPr>
-              <a:t>Phloem</a:t>
+              <a:t>Inside the xylem vessels</a:t>
             </a:r>
             <a:endParaRPr lang="en-US" sz="1700" dirty="0"/>
           </a:p>
@@ -4738,7 +3141,7 @@
                 <a:ea typeface="Arial" pitchFamily="34" charset="-122"/>
                 <a:cs typeface="Arial" pitchFamily="34" charset="-120"/>
               </a:rPr>
-              <a:t>QUESTION 3 OF 10</a:t>
+              <a:t>QUESTION 3 OF 7</a:t>
             </a:r>
             <a:endParaRPr lang="en-US" sz="1300" dirty="0"/>
           </a:p>
@@ -4830,7 +3233,7 @@
               <a:buNone/>
             </a:pPr>
             <a:r>
-              <a:rPr lang="en-US" sz="2300" b="1" dirty="0">
+              <a:rPr lang="en-US" sz="2000" b="1" dirty="0">
                 <a:solidFill>
                   <a:srgbClr val="FFFFFF"/>
                 </a:solidFill>
@@ -4838,9 +3241,9 @@
                 <a:ea typeface="Arial" pitchFamily="34" charset="-122"/>
                 <a:cs typeface="Arial" pitchFamily="34" charset="-120"/>
               </a:rPr>
-              <a:t>The spongy mesophyll has many air spaces between its cells. What is the main advantage of these air spaces?</a:t>
-            </a:r>
-            <a:endParaRPr lang="en-US" sz="2300" dirty="0"/>
+              <a:t>The spongy mesophyll of a leaf has many air spaces between its loosely arranged cells. What is the main function of these air spaces?</a:t>
+            </a:r>
+            <a:endParaRPr lang="en-US" sz="2000" dirty="0"/>
           </a:p>
         </p:txBody>
       </p:sp>
@@ -4938,7 +3341,7 @@
                 <a:ea typeface="Arial" pitchFamily="34" charset="-122"/>
                 <a:cs typeface="Arial" pitchFamily="34" charset="-120"/>
               </a:rPr>
-              <a:t>They carry sugars away from the leaf to the stem</a:t>
+              <a:t>They absorb sunlight for the palisade cells</a:t>
             </a:r>
             <a:endParaRPr lang="en-US" sz="1700" dirty="0"/>
           </a:p>
@@ -5038,7 +3441,7 @@
                 <a:ea typeface="Arial" pitchFamily="34" charset="-122"/>
                 <a:cs typeface="Arial" pitchFamily="34" charset="-120"/>
               </a:rPr>
-              <a:t>They absorb sunlight that passes through the epidermis</a:t>
+              <a:t>They let carbon dioxide diffuse from the stomata to the photosynthesising cells</a:t>
             </a:r>
             <a:endParaRPr lang="en-US" sz="1700" dirty="0"/>
           </a:p>
@@ -5138,7 +3541,7 @@
                 <a:ea typeface="Arial" pitchFamily="34" charset="-122"/>
                 <a:cs typeface="Arial" pitchFamily="34" charset="-120"/>
               </a:rPr>
-              <a:t>They store extra water for the leaf to use at midday</a:t>
+              <a:t>They store sugars made during photosynthesis</a:t>
             </a:r>
             <a:endParaRPr lang="en-US" sz="1700" dirty="0"/>
           </a:p>
@@ -5238,7 +3641,7 @@
                 <a:ea typeface="Arial" pitchFamily="34" charset="-122"/>
                 <a:cs typeface="Arial" pitchFamily="34" charset="-120"/>
               </a:rPr>
-              <a:t>They let carbon dioxide diffuse easily to the cells inside the leaf</a:t>
+              <a:t>They carry water from the roots to the leaf</a:t>
             </a:r>
             <a:endParaRPr lang="en-US" sz="1700" dirty="0"/>
           </a:p>
@@ -5348,7 +3751,7 @@
                 <a:ea typeface="Arial" pitchFamily="34" charset="-122"/>
                 <a:cs typeface="Arial" pitchFamily="34" charset="-120"/>
               </a:rPr>
-              <a:t>QUESTION 4 OF 10</a:t>
+              <a:t>QUESTION 4 OF 7</a:t>
             </a:r>
             <a:endParaRPr lang="en-US" sz="1300" dirty="0"/>
           </a:p>
@@ -5448,7 +3851,7 @@
                 <a:ea typeface="Arial" pitchFamily="34" charset="-122"/>
                 <a:cs typeface="Arial" pitchFamily="34" charset="-120"/>
               </a:rPr>
-              <a:t>A vascular bundle in a leaf contains xylem and phloem. Which statement describes their jobs correctly?</a:t>
+              <a:t>A leaf vein (vascular bundle) contains xylem and phloem. Which statement correctly describes their roles?</a:t>
             </a:r>
             <a:endParaRPr lang="en-US" sz="2300" dirty="0"/>
           </a:p>
@@ -5540,7 +3943,7 @@
               <a:buNone/>
             </a:pPr>
             <a:r>
-              <a:rPr lang="en-US" sz="1700" dirty="0">
+              <a:rPr lang="en-US" sz="1500" dirty="0">
                 <a:solidFill>
                   <a:srgbClr val="FFFFFF"/>
                 </a:solidFill>
@@ -5548,9 +3951,9 @@
                 <a:ea typeface="Arial" pitchFamily="34" charset="-122"/>
                 <a:cs typeface="Arial" pitchFamily="34" charset="-120"/>
               </a:rPr>
-              <a:t>Xylem brings water and minerals to the leaf and phloem carries sugars away</a:t>
-            </a:r>
-            <a:endParaRPr lang="en-US" sz="1700" dirty="0"/>
+              <a:t>Both carry only gases in and out of the leaf</a:t>
+            </a:r>
+            <a:endParaRPr lang="en-US" sz="1500" dirty="0"/>
           </a:p>
         </p:txBody>
       </p:sp>
@@ -5640,7 +4043,7 @@
               <a:buNone/>
             </a:pPr>
             <a:r>
-              <a:rPr lang="en-US" sz="1700" dirty="0">
+              <a:rPr lang="en-US" sz="1500" dirty="0">
                 <a:solidFill>
                   <a:srgbClr val="FFFFFF"/>
                 </a:solidFill>
@@ -5648,9 +4051,9 @@
                 <a:ea typeface="Arial" pitchFamily="34" charset="-122"/>
                 <a:cs typeface="Arial" pitchFamily="34" charset="-120"/>
               </a:rPr>
-              <a:t>Xylem carries sugars out of the leaf and phloem brings water into the leaf</a:t>
-            </a:r>
-            <a:endParaRPr lang="en-US" sz="1700" dirty="0"/>
+              <a:t>Xylem brings water and minerals into the leaf, and phloem carries sugars away from the leaf</a:t>
+            </a:r>
+            <a:endParaRPr lang="en-US" sz="1500" dirty="0"/>
           </a:p>
         </p:txBody>
       </p:sp>
@@ -5740,7 +4143,7 @@
               <a:buNone/>
             </a:pPr>
             <a:r>
-              <a:rPr lang="en-US" sz="1700" dirty="0">
+              <a:rPr lang="en-US" sz="1500" dirty="0">
                 <a:solidFill>
                   <a:srgbClr val="FFFFFF"/>
                 </a:solidFill>
@@ -5748,9 +4151,9 @@
                 <a:ea typeface="Arial" pitchFamily="34" charset="-122"/>
                 <a:cs typeface="Arial" pitchFamily="34" charset="-120"/>
               </a:rPr>
-              <a:t>Xylem and phloem both carry only carbon dioxide to the palisade cells</a:t>
-            </a:r>
-            <a:endParaRPr lang="en-US" sz="1700" dirty="0"/>
+              <a:t>Xylem carries sugars away from the leaf, and phloem brings water and minerals in</a:t>
+            </a:r>
+            <a:endParaRPr lang="en-US" sz="1500" dirty="0"/>
           </a:p>
         </p:txBody>
       </p:sp>
@@ -5840,7 +4243,7 @@
               <a:buNone/>
             </a:pPr>
             <a:r>
-              <a:rPr lang="en-US" sz="1700" dirty="0">
+              <a:rPr lang="en-US" sz="1500" dirty="0">
                 <a:solidFill>
                   <a:srgbClr val="FFFFFF"/>
                 </a:solidFill>
@@ -5848,9 +4251,9 @@
                 <a:ea typeface="Arial" pitchFamily="34" charset="-122"/>
                 <a:cs typeface="Arial" pitchFamily="34" charset="-120"/>
               </a:rPr>
-              <a:t>Xylem lets in light and phloem controls the opening of stomata</a:t>
-            </a:r>
-            <a:endParaRPr lang="en-US" sz="1700" dirty="0"/>
+              <a:t>Xylem absorbs light, and phloem prevents water loss</a:t>
+            </a:r>
+            <a:endParaRPr lang="en-US" sz="1500" dirty="0"/>
           </a:p>
         </p:txBody>
       </p:sp>
@@ -5958,7 +4361,7 @@
                 <a:ea typeface="Arial" pitchFamily="34" charset="-122"/>
                 <a:cs typeface="Arial" pitchFamily="34" charset="-120"/>
               </a:rPr>
-              <a:t>QUESTION 5 OF 10</a:t>
+              <a:t>QUESTION 5 OF 7</a:t>
             </a:r>
             <a:endParaRPr lang="en-US" sz="1300" dirty="0"/>
           </a:p>
@@ -6050,7 +4453,7 @@
               <a:buNone/>
             </a:pPr>
             <a:r>
-              <a:rPr lang="en-US" sz="2300" b="1" dirty="0">
+              <a:rPr lang="en-US" sz="2000" b="1" dirty="0">
                 <a:solidFill>
                   <a:srgbClr val="FFFFFF"/>
                 </a:solidFill>
@@ -6058,9 +4461,9 @@
                 <a:ea typeface="Arial" pitchFamily="34" charset="-122"/>
                 <a:cs typeface="Arial" pitchFamily="34" charset="-120"/>
               </a:rPr>
-              <a:t>The cuticle and the epidermis of a leaf are transparent (clear). Why is this useful to the plant?</a:t>
-            </a:r>
-            <a:endParaRPr lang="en-US" sz="2300" dirty="0"/>
+              <a:t>Kale (sukuma wiki) plants in a Nairobi garden wilt at midday even though the soil is moist, then recover the next morning. Which explanation best fits leaf structure?</a:t>
+            </a:r>
+            <a:endParaRPr lang="en-US" sz="2000" dirty="0"/>
           </a:p>
         </p:txBody>
       </p:sp>
@@ -6150,7 +4553,7 @@
               <a:buNone/>
             </a:pPr>
             <a:r>
-              <a:rPr lang="en-US" sz="1700" dirty="0">
+              <a:rPr lang="en-US" sz="1300" dirty="0">
                 <a:solidFill>
                   <a:srgbClr val="FFFFFF"/>
                 </a:solidFill>
@@ -6158,9 +4561,9 @@
                 <a:ea typeface="Arial" pitchFamily="34" charset="-122"/>
                 <a:cs typeface="Arial" pitchFamily="34" charset="-120"/>
               </a:rPr>
-              <a:t>It allows water vapour to escape freely from the whole leaf surface</a:t>
-            </a:r>
-            <a:endParaRPr lang="en-US" sz="1700" dirty="0"/>
+              <a:t>In strong sun the stomata open wide, so water vapour escapes faster than the xylem can supply water, and the cells lose turgor</a:t>
+            </a:r>
+            <a:endParaRPr lang="en-US" sz="1300" dirty="0"/>
           </a:p>
         </p:txBody>
       </p:sp>
@@ -6250,7 +4653,7 @@
               <a:buNone/>
             </a:pPr>
             <a:r>
-              <a:rPr lang="en-US" sz="1700" dirty="0">
+              <a:rPr lang="en-US" sz="1300" dirty="0">
                 <a:solidFill>
                   <a:srgbClr val="FFFFFF"/>
                 </a:solidFill>
@@ -6258,9 +4661,9 @@
                 <a:ea typeface="Arial" pitchFamily="34" charset="-122"/>
                 <a:cs typeface="Arial" pitchFamily="34" charset="-120"/>
               </a:rPr>
-              <a:t>It lets air spaces fill with sunlight at night</a:t>
-            </a:r>
-            <a:endParaRPr lang="en-US" sz="1700" dirty="0"/>
+              <a:t>The xylem vessels are permanently damaged by the sun and then repair themselves overnight</a:t>
+            </a:r>
+            <a:endParaRPr lang="en-US" sz="1300" dirty="0"/>
           </a:p>
         </p:txBody>
       </p:sp>
@@ -6350,7 +4753,7 @@
               <a:buNone/>
             </a:pPr>
             <a:r>
-              <a:rPr lang="en-US" sz="1700" dirty="0">
+              <a:rPr lang="en-US" sz="1300" dirty="0">
                 <a:solidFill>
                   <a:srgbClr val="FFFFFF"/>
                 </a:solidFill>
@@ -6358,9 +4761,9 @@
                 <a:ea typeface="Arial" pitchFamily="34" charset="-122"/>
                 <a:cs typeface="Arial" pitchFamily="34" charset="-120"/>
               </a:rPr>
-              <a:t>It helps the xylem to see where water is needed</a:t>
-            </a:r>
-            <a:endParaRPr lang="en-US" sz="1700" dirty="0"/>
+              <a:t>The chloroplasts in the palisade cells burst at midday and are replaced at night</a:t>
+            </a:r>
+            <a:endParaRPr lang="en-US" sz="1300" dirty="0"/>
           </a:p>
         </p:txBody>
       </p:sp>
@@ -6450,7 +4853,7 @@
               <a:buNone/>
             </a:pPr>
             <a:r>
-              <a:rPr lang="en-US" sz="1700" dirty="0">
+              <a:rPr lang="en-US" sz="1300" dirty="0">
                 <a:solidFill>
                   <a:srgbClr val="FFFFFF"/>
                 </a:solidFill>
@@ -6458,9 +4861,9 @@
                 <a:ea typeface="Arial" pitchFamily="34" charset="-122"/>
                 <a:cs typeface="Arial" pitchFamily="34" charset="-120"/>
               </a:rPr>
-              <a:t>It lets light pass through to the chloroplasts in the cells below</a:t>
-            </a:r>
-            <a:endParaRPr lang="en-US" sz="1700" dirty="0"/>
+              <a:t>The soil loses all its water at midday and gets it back at night</a:t>
+            </a:r>
+            <a:endParaRPr lang="en-US" sz="1300" dirty="0"/>
           </a:p>
         </p:txBody>
       </p:sp>
@@ -6568,7 +4971,7 @@
                 <a:ea typeface="Arial" pitchFamily="34" charset="-122"/>
                 <a:cs typeface="Arial" pitchFamily="34" charset="-120"/>
               </a:rPr>
-              <a:t>QUESTION 6 OF 10</a:t>
+              <a:t>QUESTION 6 OF 7</a:t>
             </a:r>
             <a:endParaRPr lang="en-US" sz="1300" dirty="0"/>
           </a:p>
@@ -6660,7 +5063,7 @@
               <a:buNone/>
             </a:pPr>
             <a:r>
-              <a:rPr lang="en-US" sz="2300" b="1" dirty="0">
+              <a:rPr lang="en-US" sz="1800" b="1" dirty="0">
                 <a:solidFill>
                   <a:srgbClr val="FFFFFF"/>
                 </a:solidFill>
@@ -6668,9 +5071,9 @@
                 <a:ea typeface="Arial" pitchFamily="34" charset="-122"/>
                 <a:cs typeface="Arial" pitchFamily="34" charset="-120"/>
               </a:rPr>
-              <a:t>What is the job of the two guard cells around a stoma?</a:t>
-            </a:r>
-            <a:endParaRPr lang="en-US" sz="2300" dirty="0"/>
+              <a:t>Kale plants moved under the shade of a mango tree stop wilting, but over several weeks the leaves turn pale yellowish-green and the plants grow slowly. Which explanation uses leaf structure correctly?</a:t>
+            </a:r>
+            <a:endParaRPr lang="en-US" sz="1800" dirty="0"/>
           </a:p>
         </p:txBody>
       </p:sp>
@@ -6760,7 +5163,7 @@
               <a:buNone/>
             </a:pPr>
             <a:r>
-              <a:rPr lang="en-US" sz="1700" dirty="0">
+              <a:rPr lang="en-US" sz="1500" dirty="0">
                 <a:solidFill>
                   <a:srgbClr val="FFFFFF"/>
                 </a:solidFill>
@@ -6768,9 +5171,9 @@
                 <a:ea typeface="Arial" pitchFamily="34" charset="-122"/>
                 <a:cs typeface="Arial" pitchFamily="34" charset="-120"/>
               </a:rPr>
-              <a:t>To protect the leaf by making a thick waxy layer</a:t>
-            </a:r>
-            <a:endParaRPr lang="en-US" sz="1700" dirty="0"/>
+              <a:t>Shade makes the cuticle thicker, which traps too much water in the leaf</a:t>
+            </a:r>
+            <a:endParaRPr lang="en-US" sz="1500" dirty="0"/>
           </a:p>
         </p:txBody>
       </p:sp>
@@ -6860,7 +5263,7 @@
               <a:buNone/>
             </a:pPr>
             <a:r>
-              <a:rPr lang="en-US" sz="1700" dirty="0">
+              <a:rPr lang="en-US" sz="1500" dirty="0">
                 <a:solidFill>
                   <a:srgbClr val="FFFFFF"/>
                 </a:solidFill>
@@ -6868,9 +5271,9 @@
                 <a:ea typeface="Arial" pitchFamily="34" charset="-122"/>
                 <a:cs typeface="Arial" pitchFamily="34" charset="-120"/>
               </a:rPr>
-              <a:t>To carry water from the roots to the leaf</a:t>
-            </a:r>
-            <a:endParaRPr lang="en-US" sz="1700" dirty="0"/>
+              <a:t>Less light reaches the palisade cells, so less photosynthesis happens, leading to pale leaves and slow growth</a:t>
+            </a:r>
+            <a:endParaRPr lang="en-US" sz="1500" dirty="0"/>
           </a:p>
         </p:txBody>
       </p:sp>
@@ -6960,7 +5363,7 @@
               <a:buNone/>
             </a:pPr>
             <a:r>
-              <a:rPr lang="en-US" sz="1700" dirty="0">
+              <a:rPr lang="en-US" sz="1500" dirty="0">
                 <a:solidFill>
                   <a:srgbClr val="FFFFFF"/>
                 </a:solidFill>
@@ -6968,9 +5371,9 @@
                 <a:ea typeface="Arial" pitchFamily="34" charset="-122"/>
                 <a:cs typeface="Arial" pitchFamily="34" charset="-120"/>
               </a:rPr>
-              <a:t>To open and close the stoma, controlling gas exchange and water vapour loss</a:t>
-            </a:r>
-            <a:endParaRPr lang="en-US" sz="1700" dirty="0"/>
+              <a:t>Shade blocks all gas exchange because the stomata are sealed shut permanently</a:t>
+            </a:r>
+            <a:endParaRPr lang="en-US" sz="1500" dirty="0"/>
           </a:p>
         </p:txBody>
       </p:sp>
@@ -7060,7 +5463,7 @@
               <a:buNone/>
             </a:pPr>
             <a:r>
-              <a:rPr lang="en-US" sz="1700" dirty="0">
+              <a:rPr lang="en-US" sz="1500" dirty="0">
                 <a:solidFill>
                   <a:srgbClr val="FFFFFF"/>
                 </a:solidFill>
@@ -7068,9 +5471,9 @@
                 <a:ea typeface="Arial" pitchFamily="34" charset="-122"/>
                 <a:cs typeface="Arial" pitchFamily="34" charset="-120"/>
               </a:rPr>
-              <a:t>To make sugars using sunlight</a:t>
-            </a:r>
-            <a:endParaRPr lang="en-US" sz="1700" dirty="0"/>
+              <a:t>Shade makes the xylem carry sugars instead of water</a:t>
+            </a:r>
+            <a:endParaRPr lang="en-US" sz="1500" dirty="0"/>
           </a:p>
         </p:txBody>
       </p:sp>
@@ -7178,7 +5581,7 @@
                 <a:ea typeface="Arial" pitchFamily="34" charset="-122"/>
                 <a:cs typeface="Arial" pitchFamily="34" charset="-120"/>
               </a:rPr>
-              <a:t>QUESTION 7 OF 10</a:t>
+              <a:t>QUESTION 7 OF 7</a:t>
             </a:r>
             <a:endParaRPr lang="en-US" sz="1300" dirty="0"/>
           </a:p>
@@ -7239,7 +5642,7 @@
                 <a:ea typeface="Arial" pitchFamily="34" charset="-122"/>
                 <a:cs typeface="Arial" pitchFamily="34" charset="-120"/>
               </a:rPr>
-              <a:t>Use after: Explain phase</a:t>
+              <a:t>Use after: Model Building phase</a:t>
             </a:r>
             <a:endParaRPr lang="en-US" sz="1100" dirty="0"/>
           </a:p>
@@ -7270,7 +5673,7 @@
               <a:buNone/>
             </a:pPr>
             <a:r>
-              <a:rPr lang="en-US" sz="2000" b="1" dirty="0">
+              <a:rPr lang="en-US" sz="2300" b="1" dirty="0">
                 <a:solidFill>
                   <a:srgbClr val="FFFFFF"/>
                 </a:solidFill>
@@ -7278,9 +5681,9 @@
                 <a:ea typeface="Arial" pitchFamily="34" charset="-122"/>
                 <a:cs typeface="Arial" pitchFamily="34" charset="-120"/>
               </a:rPr>
-              <a:t>At midday in bright sun, a kale plant's stomata are wide open. The soil is still moist, yet the leaves wilt. Which explanation fits the leaf structure best?</a:t>
-            </a:r>
-            <a:endParaRPr lang="en-US" sz="2000" dirty="0"/>
+              <a:t>A student revises her model of a sukuma wiki leaf by adding labelled arrows. Which set of arrows is correct?</a:t>
+            </a:r>
+            <a:endParaRPr lang="en-US" sz="2300" dirty="0"/>
           </a:p>
         </p:txBody>
       </p:sp>
@@ -7378,7 +5781,7 @@
                 <a:ea typeface="Arial" pitchFamily="34" charset="-122"/>
                 <a:cs typeface="Arial" pitchFamily="34" charset="-120"/>
               </a:rPr>
-              <a:t>The guard cells close completely and trap heat inside the leaf</a:t>
+              <a:t>Light enters through the xylem; water moves up the cuticle; water vapour exits through the palisade cells</a:t>
             </a:r>
             <a:endParaRPr lang="en-US" sz="1500" dirty="0"/>
           </a:p>
@@ -7478,7 +5881,7 @@
                 <a:ea typeface="Arial" pitchFamily="34" charset="-122"/>
                 <a:cs typeface="Arial" pitchFamily="34" charset="-120"/>
               </a:rPr>
-              <a:t>Water vapour leaves through the open stomata faster than the xylem can replace it, so the cells lose turgor</a:t>
+              <a:t>Light enters from above through the epidermis; water moves up the xylem; water vapour exits through the stoma</a:t>
             </a:r>
             <a:endParaRPr lang="en-US" sz="1500" dirty="0"/>
           </a:p>
@@ -7578,7 +5981,7 @@
                 <a:ea typeface="Arial" pitchFamily="34" charset="-122"/>
                 <a:cs typeface="Arial" pitchFamily="34" charset="-120"/>
               </a:rPr>
-              <a:t>The roots have permanently died, so no water can enter the plant</a:t>
+              <a:t>Light enters from below; water moves down the xylem; sugars leave through the stoma</a:t>
             </a:r>
             <a:endParaRPr lang="en-US" sz="1500" dirty="0"/>
           </a:p>
@@ -7678,7 +6081,7 @@
                 <a:ea typeface="Arial" pitchFamily="34" charset="-122"/>
                 <a:cs typeface="Arial" pitchFamily="34" charset="-120"/>
               </a:rPr>
-              <a:t>Too much water enters the leaf cells and they burst</a:t>
+              <a:t>Light enters through the lower epidermis only; water moves up the phloem; oxygen enters the xylem</a:t>
             </a:r>
             <a:endParaRPr lang="en-US" sz="1500" dirty="0"/>
           </a:p>
@@ -7737,7 +6140,7 @@
     <p:bg>
       <p:bgPr>
         <a:solidFill>
-          <a:srgbClr val="6A4C93"/>
+          <a:srgbClr val="1F3864"/>
         </a:solidFill>
       </p:bgPr>
     </p:bg>
@@ -7763,124 +6166,24 @@
         </p:nvSpPr>
         <p:spPr>
           <a:xfrm>
-            <a:off x="548640" y="365760"/>
-            <a:ext cx="6400800" cy="365760"/>
-          </a:xfrm>
-          <a:prstGeom prst="rect">
-            <a:avLst/>
-          </a:prstGeom>
-          <a:noFill/>
-          <a:ln/>
-        </p:spPr>
-        <p:txBody>
-          <a:bodyPr wrap="square" lIns="0" tIns="0" rIns="0" bIns="0" rtlCol="0" anchor="ctr"/>
-          <a:lstStyle/>
-          <a:p>
-            <a:pPr indent="0" marL="0">
-              <a:buNone/>
-            </a:pPr>
-            <a:r>
-              <a:rPr lang="en-US" sz="1300" b="1" spc="200" kern="0" dirty="0">
-                <a:solidFill>
-                  <a:srgbClr val="E0D6F0"/>
-                </a:solidFill>
-                <a:latin typeface="Arial" pitchFamily="34" charset="0"/>
-                <a:ea typeface="Arial" pitchFamily="34" charset="-122"/>
-                <a:cs typeface="Arial" pitchFamily="34" charset="-120"/>
-              </a:rPr>
-              <a:t>QUESTION 8 OF 10</a:t>
-            </a:r>
-            <a:endParaRPr lang="en-US" sz="1300" dirty="0"/>
-          </a:p>
-        </p:txBody>
-      </p:sp>
-      <p:sp>
-        <p:nvSpPr>
-          <p:cNvPr id="3" name="Shape 1"/>
-          <p:cNvSpPr/>
-          <p:nvPr/>
-        </p:nvSpPr>
-        <p:spPr>
-          <a:xfrm>
-            <a:off x="8138160" y="320040"/>
-            <a:ext cx="3474720" cy="365760"/>
-          </a:xfrm>
-          <a:prstGeom prst="roundRect">
-            <a:avLst>
-              <a:gd name="adj" fmla="val 15000"/>
-            </a:avLst>
-          </a:prstGeom>
-          <a:solidFill>
-            <a:srgbClr val="5A3F80"/>
-          </a:solidFill>
-          <a:ln/>
-        </p:spPr>
-      </p:sp>
-      <p:sp>
-        <p:nvSpPr>
-          <p:cNvPr id="4" name="Text 2"/>
-          <p:cNvSpPr/>
-          <p:nvPr/>
-        </p:nvSpPr>
-        <p:spPr>
-          <a:xfrm>
-            <a:off x="8138160" y="320040"/>
-            <a:ext cx="3474720" cy="365760"/>
-          </a:xfrm>
-          <a:prstGeom prst="rect">
-            <a:avLst/>
-          </a:prstGeom>
-          <a:noFill/>
-          <a:ln/>
-        </p:spPr>
-        <p:txBody>
-          <a:bodyPr wrap="square" lIns="0" tIns="0" rIns="0" bIns="0" rtlCol="0" anchor="ctr"/>
-          <a:lstStyle/>
-          <a:p>
-            <a:pPr algn="ctr" indent="0" marL="0">
-              <a:buNone/>
-            </a:pPr>
-            <a:r>
-              <a:rPr lang="en-US" sz="1100" i="1" dirty="0">
-                <a:solidFill>
-                  <a:srgbClr val="E0D6F0"/>
-                </a:solidFill>
-                <a:latin typeface="Arial" pitchFamily="34" charset="0"/>
-                <a:ea typeface="Arial" pitchFamily="34" charset="-122"/>
-                <a:cs typeface="Arial" pitchFamily="34" charset="-120"/>
-              </a:rPr>
-              <a:t>Use after: End of lesson</a:t>
-            </a:r>
-            <a:endParaRPr lang="en-US" sz="1100" dirty="0"/>
-          </a:p>
-        </p:txBody>
-      </p:sp>
-      <p:sp>
-        <p:nvSpPr>
-          <p:cNvPr id="5" name="Text 3"/>
-          <p:cNvSpPr/>
-          <p:nvPr/>
-        </p:nvSpPr>
-        <p:spPr>
-          <a:xfrm>
-            <a:off x="548640" y="868680"/>
-            <a:ext cx="11064240" cy="1325880"/>
-          </a:xfrm>
-          <a:prstGeom prst="rect">
-            <a:avLst/>
-          </a:prstGeom>
-          <a:noFill/>
-          <a:ln/>
-        </p:spPr>
-        <p:txBody>
-          <a:bodyPr wrap="square" lIns="0" tIns="0" rIns="0" bIns="0" rtlCol="0" anchor="ctr"/>
-          <a:lstStyle/>
-          <a:p>
-            <a:pPr indent="0" marL="0">
-              <a:buNone/>
-            </a:pPr>
-            <a:r>
-              <a:rPr lang="en-US" sz="2000" b="1" dirty="0">
+            <a:off x="731520" y="2194560"/>
+            <a:ext cx="10698480" cy="822960"/>
+          </a:xfrm>
+          <a:prstGeom prst="rect">
+            <a:avLst/>
+          </a:prstGeom>
+          <a:noFill/>
+          <a:ln/>
+        </p:spPr>
+        <p:txBody>
+          <a:bodyPr wrap="square" lIns="0" tIns="0" rIns="0" bIns="0" rtlCol="0" anchor="ctr"/>
+          <a:lstStyle/>
+          <a:p>
+            <a:pPr indent="0" marL="0">
+              <a:buNone/>
+            </a:pPr>
+            <a:r>
+              <a:rPr lang="en-US" sz="3400" b="1" dirty="0">
                 <a:solidFill>
                   <a:srgbClr val="FFFFFF"/>
                 </a:solidFill>
@@ -7888,448 +6191,48 @@
                 <a:ea typeface="Arial" pitchFamily="34" charset="-122"/>
                 <a:cs typeface="Arial" pitchFamily="34" charset="-120"/>
               </a:rPr>
-              <a:t>A kale plant is moved under the shade of a mango tree. Wilting stops, but over several weeks the leaves turn pale and the plant grows slowly. Which explanation uses leaf structure correctly?</a:t>
-            </a:r>
-            <a:endParaRPr lang="en-US" sz="2000" dirty="0"/>
-          </a:p>
-        </p:txBody>
-      </p:sp>
-      <p:sp>
-        <p:nvSpPr>
-          <p:cNvPr id="6" name="Shape 4"/>
-          <p:cNvSpPr/>
-          <p:nvPr/>
-        </p:nvSpPr>
-        <p:spPr>
-          <a:xfrm>
-            <a:off x="731520" y="2331720"/>
-            <a:ext cx="10698480" cy="777240"/>
-          </a:xfrm>
-          <a:prstGeom prst="roundRect">
-            <a:avLst>
-              <a:gd name="adj" fmla="val 9412"/>
-            </a:avLst>
-          </a:prstGeom>
-          <a:solidFill>
-            <a:srgbClr val="7C5CAA"/>
-          </a:solidFill>
-          <a:ln/>
-        </p:spPr>
-      </p:sp>
-      <p:sp>
-        <p:nvSpPr>
-          <p:cNvPr id="7" name="Text 5"/>
-          <p:cNvSpPr/>
-          <p:nvPr/>
-        </p:nvSpPr>
-        <p:spPr>
-          <a:xfrm>
-            <a:off x="914400" y="2331720"/>
-            <a:ext cx="548640" cy="777240"/>
-          </a:xfrm>
-          <a:prstGeom prst="rect">
-            <a:avLst/>
-          </a:prstGeom>
-          <a:noFill/>
-          <a:ln/>
-        </p:spPr>
-        <p:txBody>
-          <a:bodyPr wrap="square" lIns="0" tIns="0" rIns="0" bIns="0" rtlCol="0" anchor="ctr"/>
-          <a:lstStyle/>
-          <a:p>
-            <a:pPr indent="0" marL="0">
-              <a:buNone/>
-            </a:pPr>
-            <a:r>
-              <a:rPr lang="en-US" sz="1800" b="1" dirty="0">
-                <a:solidFill>
-                  <a:srgbClr val="FFFFFF"/>
-                </a:solidFill>
-                <a:latin typeface="Arial" pitchFamily="34" charset="0"/>
-                <a:ea typeface="Arial" pitchFamily="34" charset="-122"/>
-                <a:cs typeface="Arial" pitchFamily="34" charset="-120"/>
-              </a:rPr>
-              <a:t>A</a:t>
+              <a:t>All done</a:t>
+            </a:r>
+            <a:endParaRPr lang="en-US" sz="3400" dirty="0"/>
+          </a:p>
+        </p:txBody>
+      </p:sp>
+      <p:sp>
+        <p:nvSpPr>
+          <p:cNvPr id="3" name="Text 1"/>
+          <p:cNvSpPr/>
+          <p:nvPr/>
+        </p:nvSpPr>
+        <p:spPr>
+          <a:xfrm>
+            <a:off x="731520" y="3108960"/>
+            <a:ext cx="10698480" cy="731520"/>
+          </a:xfrm>
+          <a:prstGeom prst="rect">
+            <a:avLst/>
+          </a:prstGeom>
+          <a:noFill/>
+          <a:ln/>
+        </p:spPr>
+        <p:txBody>
+          <a:bodyPr wrap="square" lIns="0" tIns="0" rIns="0" bIns="0" rtlCol="0" anchor="ctr"/>
+          <a:lstStyle/>
+          <a:p>
+            <a:pPr indent="0" marL="0">
+              <a:buNone/>
+            </a:pPr>
+            <a:r>
+              <a:rPr lang="en-US" sz="1800" dirty="0">
+                <a:solidFill>
+                  <a:srgbClr val="D9EEF1"/>
+                </a:solidFill>
+                <a:latin typeface="Arial" pitchFamily="34" charset="0"/>
+                <a:ea typeface="Arial" pitchFamily="34" charset="-122"/>
+                <a:cs typeface="Arial" pitchFamily="34" charset="-120"/>
+              </a:rPr>
+              <a:t>Ask your teacher how to submit your answers today (for example, on a paper answer slip).</a:t>
             </a:r>
             <a:endParaRPr lang="en-US" sz="1800" dirty="0"/>
-          </a:p>
-        </p:txBody>
-      </p:sp>
-      <p:sp>
-        <p:nvSpPr>
-          <p:cNvPr id="8" name="Text 6"/>
-          <p:cNvSpPr/>
-          <p:nvPr/>
-        </p:nvSpPr>
-        <p:spPr>
-          <a:xfrm>
-            <a:off x="1554480" y="2331720"/>
-            <a:ext cx="9692640" cy="777240"/>
-          </a:xfrm>
-          <a:prstGeom prst="rect">
-            <a:avLst/>
-          </a:prstGeom>
-          <a:noFill/>
-          <a:ln/>
-        </p:spPr>
-        <p:txBody>
-          <a:bodyPr wrap="square" lIns="0" tIns="0" rIns="0" bIns="0" rtlCol="0" anchor="ctr"/>
-          <a:lstStyle/>
-          <a:p>
-            <a:pPr indent="0" marL="0">
-              <a:buNone/>
-            </a:pPr>
-            <a:r>
-              <a:rPr lang="en-US" sz="1500" dirty="0">
-                <a:solidFill>
-                  <a:srgbClr val="FFFFFF"/>
-                </a:solidFill>
-                <a:latin typeface="Arial" pitchFamily="34" charset="0"/>
-                <a:ea typeface="Arial" pitchFamily="34" charset="-122"/>
-                <a:cs typeface="Arial" pitchFamily="34" charset="-120"/>
-              </a:rPr>
-              <a:t>The shade blocks the xylem, so no water can reach the leaf</a:t>
-            </a:r>
-            <a:endParaRPr lang="en-US" sz="1500" dirty="0"/>
-          </a:p>
-        </p:txBody>
-      </p:sp>
-      <p:sp>
-        <p:nvSpPr>
-          <p:cNvPr id="9" name="Shape 7"/>
-          <p:cNvSpPr/>
-          <p:nvPr/>
-        </p:nvSpPr>
-        <p:spPr>
-          <a:xfrm>
-            <a:off x="731520" y="3246120"/>
-            <a:ext cx="10698480" cy="777240"/>
-          </a:xfrm>
-          <a:prstGeom prst="roundRect">
-            <a:avLst>
-              <a:gd name="adj" fmla="val 9412"/>
-            </a:avLst>
-          </a:prstGeom>
-          <a:solidFill>
-            <a:srgbClr val="7C5CAA"/>
-          </a:solidFill>
-          <a:ln/>
-        </p:spPr>
-      </p:sp>
-      <p:sp>
-        <p:nvSpPr>
-          <p:cNvPr id="10" name="Text 8"/>
-          <p:cNvSpPr/>
-          <p:nvPr/>
-        </p:nvSpPr>
-        <p:spPr>
-          <a:xfrm>
-            <a:off x="914400" y="3246120"/>
-            <a:ext cx="548640" cy="777240"/>
-          </a:xfrm>
-          <a:prstGeom prst="rect">
-            <a:avLst/>
-          </a:prstGeom>
-          <a:noFill/>
-          <a:ln/>
-        </p:spPr>
-        <p:txBody>
-          <a:bodyPr wrap="square" lIns="0" tIns="0" rIns="0" bIns="0" rtlCol="0" anchor="ctr"/>
-          <a:lstStyle/>
-          <a:p>
-            <a:pPr indent="0" marL="0">
-              <a:buNone/>
-            </a:pPr>
-            <a:r>
-              <a:rPr lang="en-US" sz="1800" b="1" dirty="0">
-                <a:solidFill>
-                  <a:srgbClr val="FFFFFF"/>
-                </a:solidFill>
-                <a:latin typeface="Arial" pitchFamily="34" charset="0"/>
-                <a:ea typeface="Arial" pitchFamily="34" charset="-122"/>
-                <a:cs typeface="Arial" pitchFamily="34" charset="-120"/>
-              </a:rPr>
-              <a:t>B</a:t>
-            </a:r>
-            <a:endParaRPr lang="en-US" sz="1800" dirty="0"/>
-          </a:p>
-        </p:txBody>
-      </p:sp>
-      <p:sp>
-        <p:nvSpPr>
-          <p:cNvPr id="11" name="Text 9"/>
-          <p:cNvSpPr/>
-          <p:nvPr/>
-        </p:nvSpPr>
-        <p:spPr>
-          <a:xfrm>
-            <a:off x="1554480" y="3246120"/>
-            <a:ext cx="9692640" cy="777240"/>
-          </a:xfrm>
-          <a:prstGeom prst="rect">
-            <a:avLst/>
-          </a:prstGeom>
-          <a:noFill/>
-          <a:ln/>
-        </p:spPr>
-        <p:txBody>
-          <a:bodyPr wrap="square" lIns="0" tIns="0" rIns="0" bIns="0" rtlCol="0" anchor="ctr"/>
-          <a:lstStyle/>
-          <a:p>
-            <a:pPr indent="0" marL="0">
-              <a:buNone/>
-            </a:pPr>
-            <a:r>
-              <a:rPr lang="en-US" sz="1500" dirty="0">
-                <a:solidFill>
-                  <a:srgbClr val="FFFFFF"/>
-                </a:solidFill>
-                <a:latin typeface="Arial" pitchFamily="34" charset="0"/>
-                <a:ea typeface="Arial" pitchFamily="34" charset="-122"/>
-                <a:cs typeface="Arial" pitchFamily="34" charset="-120"/>
-              </a:rPr>
-              <a:t>The shade makes the guard cells lose their pores</a:t>
-            </a:r>
-            <a:endParaRPr lang="en-US" sz="1500" dirty="0"/>
-          </a:p>
-        </p:txBody>
-      </p:sp>
-      <p:sp>
-        <p:nvSpPr>
-          <p:cNvPr id="12" name="Shape 10"/>
-          <p:cNvSpPr/>
-          <p:nvPr/>
-        </p:nvSpPr>
-        <p:spPr>
-          <a:xfrm>
-            <a:off x="731520" y="4160520"/>
-            <a:ext cx="10698480" cy="777240"/>
-          </a:xfrm>
-          <a:prstGeom prst="roundRect">
-            <a:avLst>
-              <a:gd name="adj" fmla="val 9412"/>
-            </a:avLst>
-          </a:prstGeom>
-          <a:solidFill>
-            <a:srgbClr val="7C5CAA"/>
-          </a:solidFill>
-          <a:ln/>
-        </p:spPr>
-      </p:sp>
-      <p:sp>
-        <p:nvSpPr>
-          <p:cNvPr id="13" name="Text 11"/>
-          <p:cNvSpPr/>
-          <p:nvPr/>
-        </p:nvSpPr>
-        <p:spPr>
-          <a:xfrm>
-            <a:off x="914400" y="4160520"/>
-            <a:ext cx="548640" cy="777240"/>
-          </a:xfrm>
-          <a:prstGeom prst="rect">
-            <a:avLst/>
-          </a:prstGeom>
-          <a:noFill/>
-          <a:ln/>
-        </p:spPr>
-        <p:txBody>
-          <a:bodyPr wrap="square" lIns="0" tIns="0" rIns="0" bIns="0" rtlCol="0" anchor="ctr"/>
-          <a:lstStyle/>
-          <a:p>
-            <a:pPr indent="0" marL="0">
-              <a:buNone/>
-            </a:pPr>
-            <a:r>
-              <a:rPr lang="en-US" sz="1800" b="1" dirty="0">
-                <a:solidFill>
-                  <a:srgbClr val="FFFFFF"/>
-                </a:solidFill>
-                <a:latin typeface="Arial" pitchFamily="34" charset="0"/>
-                <a:ea typeface="Arial" pitchFamily="34" charset="-122"/>
-                <a:cs typeface="Arial" pitchFamily="34" charset="-120"/>
-              </a:rPr>
-              <a:t>C</a:t>
-            </a:r>
-            <a:endParaRPr lang="en-US" sz="1800" dirty="0"/>
-          </a:p>
-        </p:txBody>
-      </p:sp>
-      <p:sp>
-        <p:nvSpPr>
-          <p:cNvPr id="14" name="Text 12"/>
-          <p:cNvSpPr/>
-          <p:nvPr/>
-        </p:nvSpPr>
-        <p:spPr>
-          <a:xfrm>
-            <a:off x="1554480" y="4160520"/>
-            <a:ext cx="9692640" cy="777240"/>
-          </a:xfrm>
-          <a:prstGeom prst="rect">
-            <a:avLst/>
-          </a:prstGeom>
-          <a:noFill/>
-          <a:ln/>
-        </p:spPr>
-        <p:txBody>
-          <a:bodyPr wrap="square" lIns="0" tIns="0" rIns="0" bIns="0" rtlCol="0" anchor="ctr"/>
-          <a:lstStyle/>
-          <a:p>
-            <a:pPr indent="0" marL="0">
-              <a:buNone/>
-            </a:pPr>
-            <a:r>
-              <a:rPr lang="en-US" sz="1500" dirty="0">
-                <a:solidFill>
-                  <a:srgbClr val="FFFFFF"/>
-                </a:solidFill>
-                <a:latin typeface="Arial" pitchFamily="34" charset="0"/>
-                <a:ea typeface="Arial" pitchFamily="34" charset="-122"/>
-                <a:cs typeface="Arial" pitchFamily="34" charset="-120"/>
-              </a:rPr>
-              <a:t>Less light reaches the palisade cells, so the leaf makes less food and the plant grows slowly</a:t>
-            </a:r>
-            <a:endParaRPr lang="en-US" sz="1500" dirty="0"/>
-          </a:p>
-        </p:txBody>
-      </p:sp>
-      <p:sp>
-        <p:nvSpPr>
-          <p:cNvPr id="15" name="Shape 13"/>
-          <p:cNvSpPr/>
-          <p:nvPr/>
-        </p:nvSpPr>
-        <p:spPr>
-          <a:xfrm>
-            <a:off x="731520" y="5074920"/>
-            <a:ext cx="10698480" cy="777240"/>
-          </a:xfrm>
-          <a:prstGeom prst="roundRect">
-            <a:avLst>
-              <a:gd name="adj" fmla="val 9412"/>
-            </a:avLst>
-          </a:prstGeom>
-          <a:solidFill>
-            <a:srgbClr val="7C5CAA"/>
-          </a:solidFill>
-          <a:ln/>
-        </p:spPr>
-      </p:sp>
-      <p:sp>
-        <p:nvSpPr>
-          <p:cNvPr id="16" name="Text 14"/>
-          <p:cNvSpPr/>
-          <p:nvPr/>
-        </p:nvSpPr>
-        <p:spPr>
-          <a:xfrm>
-            <a:off x="914400" y="5074920"/>
-            <a:ext cx="548640" cy="777240"/>
-          </a:xfrm>
-          <a:prstGeom prst="rect">
-            <a:avLst/>
-          </a:prstGeom>
-          <a:noFill/>
-          <a:ln/>
-        </p:spPr>
-        <p:txBody>
-          <a:bodyPr wrap="square" lIns="0" tIns="0" rIns="0" bIns="0" rtlCol="0" anchor="ctr"/>
-          <a:lstStyle/>
-          <a:p>
-            <a:pPr indent="0" marL="0">
-              <a:buNone/>
-            </a:pPr>
-            <a:r>
-              <a:rPr lang="en-US" sz="1800" b="1" dirty="0">
-                <a:solidFill>
-                  <a:srgbClr val="FFFFFF"/>
-                </a:solidFill>
-                <a:latin typeface="Arial" pitchFamily="34" charset="0"/>
-                <a:ea typeface="Arial" pitchFamily="34" charset="-122"/>
-                <a:cs typeface="Arial" pitchFamily="34" charset="-120"/>
-              </a:rPr>
-              <a:t>D</a:t>
-            </a:r>
-            <a:endParaRPr lang="en-US" sz="1800" dirty="0"/>
-          </a:p>
-        </p:txBody>
-      </p:sp>
-      <p:sp>
-        <p:nvSpPr>
-          <p:cNvPr id="17" name="Text 15"/>
-          <p:cNvSpPr/>
-          <p:nvPr/>
-        </p:nvSpPr>
-        <p:spPr>
-          <a:xfrm>
-            <a:off x="1554480" y="5074920"/>
-            <a:ext cx="9692640" cy="777240"/>
-          </a:xfrm>
-          <a:prstGeom prst="rect">
-            <a:avLst/>
-          </a:prstGeom>
-          <a:noFill/>
-          <a:ln/>
-        </p:spPr>
-        <p:txBody>
-          <a:bodyPr wrap="square" lIns="0" tIns="0" rIns="0" bIns="0" rtlCol="0" anchor="ctr"/>
-          <a:lstStyle/>
-          <a:p>
-            <a:pPr indent="0" marL="0">
-              <a:buNone/>
-            </a:pPr>
-            <a:r>
-              <a:rPr lang="en-US" sz="1500" dirty="0">
-                <a:solidFill>
-                  <a:srgbClr val="FFFFFF"/>
-                </a:solidFill>
-                <a:latin typeface="Arial" pitchFamily="34" charset="0"/>
-                <a:ea typeface="Arial" pitchFamily="34" charset="-122"/>
-                <a:cs typeface="Arial" pitchFamily="34" charset="-120"/>
-              </a:rPr>
-              <a:t>The shade makes the cuticle so thick that air cannot pass through</a:t>
-            </a:r>
-            <a:endParaRPr lang="en-US" sz="1500" dirty="0"/>
-          </a:p>
-        </p:txBody>
-      </p:sp>
-      <p:sp>
-        <p:nvSpPr>
-          <p:cNvPr id="18" name="Text 16"/>
-          <p:cNvSpPr/>
-          <p:nvPr/>
-        </p:nvSpPr>
-        <p:spPr>
-          <a:xfrm>
-            <a:off x="11521440" y="6446520"/>
-            <a:ext cx="457200" cy="274320"/>
-          </a:xfrm>
-          <a:prstGeom prst="rect">
-            <a:avLst/>
-          </a:prstGeom>
-          <a:noFill/>
-          <a:ln/>
-        </p:spPr>
-        <p:txBody>
-          <a:bodyPr wrap="square" lIns="0" tIns="0" rIns="0" bIns="0" rtlCol="0" anchor="ctr"/>
-          <a:lstStyle/>
-          <a:p>
-            <a:pPr algn="r" indent="0" marL="0">
-              <a:buNone/>
-            </a:pPr>
-            <a:r>
-              <a:rPr lang="en-US" sz="1000" dirty="0">
-                <a:solidFill>
-                  <a:srgbClr val="C9B8E0"/>
-                </a:solidFill>
-                <a:latin typeface="Arial" pitchFamily="34" charset="0"/>
-                <a:ea typeface="Arial" pitchFamily="34" charset="-122"/>
-                <a:cs typeface="Arial" pitchFamily="34" charset="-120"/>
-              </a:rPr>
-              <a:t>9</a:t>
-            </a:r>
-            <a:endParaRPr lang="en-US" sz="1000" dirty="0"/>
           </a:p>
         </p:txBody>
       </p:sp>

</xml_diff>